<commit_message>
M01-W04-L01 분량 기준 보강
골밀도만으로 판단하면 안 되는 이유, 골다공증 위험 요인을 경로별로
묶는 문단, 연골 질환이 앞의 세 범주와 성격이 다른 이유를 덧붙여
22,000자 기준을 넘긴다.

Co-Authored-By: Claude Opus 5 <noreply@anthropic.com>
Claude-Session: https://claude.ai/code/session_01TGVgH4PG4LB6Jq8r4MtGjs
</commit_message>
<xml_diff>
--- a/curriculum/M01/W04/L01/slides-2.pptx
+++ b/curriculum/M01/W04/L01/slides-2.pptx
@@ -21,7 +21,7 @@
     <p:sldId id="269" r:id="rId20"/>
     <p:sldId id="270" r:id="rId21"/>
     <p:sldId id="271" r:id="rId22"/>
-    <p:sldId id="272" r:id="rId24"/>
+    <p:sldId id="272" r:id="rId23"/>
     <p:sldId id="273" r:id="rId25"/>
     <p:sldId id="274" r:id="rId26"/>
     <p:sldId id="275" r:id="rId27"/>
@@ -45,6 +45,7 @@
     <p:sldId id="293" r:id="rId45"/>
     <p:sldId id="294" r:id="rId46"/>
     <p:sldId id="295" r:id="rId47"/>
+    <p:sldId id="296" r:id="rId48"/>
   </p:sldIdLst>
   <p:sldSz cx="12191695" cy="6858000" type="screen4x3"/>
   <p:notesSz cx="6858000" cy="9144000"/>
@@ -7278,7 +7279,7 @@
                 <a:ea typeface="Malgun Gothic"/>
                 <a:cs typeface="Malgun Gothic"/>
               </a:rPr>
-              <a:t>14. 뼈와 관절 질환을 읽는 논리</a:t>
+              <a:t>14. 뼈와 관절 질환을 읽는 논리 (1/2)</a:t>
             </a:r>
           </a:p>
         </p:txBody>
@@ -7438,6 +7439,17 @@
               <a:t>•  </a:t>
             </a:r>
             <a:r>
+              <a:rPr sz="1400" b="0" i="0">
+                <a:solidFill>
+                  <a:srgbClr val="11202B"/>
+                </a:solidFill>
+                <a:latin typeface="Malgun Gothic"/>
+                <a:ea typeface="Malgun Gothic"/>
+                <a:cs typeface="Malgun Gothic"/>
+              </a:rPr>
+              <a:t>판단의 출발점은 언제나 </a:t>
+            </a:r>
+            <a:r>
               <a:rPr sz="1400" b="1" i="0">
                 <a:solidFill>
                   <a:srgbClr val="11202B"/>
@@ -7446,7 +7458,7 @@
                 <a:ea typeface="Malgun Gothic"/>
                 <a:cs typeface="Malgun Gothic"/>
               </a:rPr>
-              <a:t>2. 무기질화가 문제인가.</a:t>
+              <a:t>골밀도가 아니라 네 가지 검사값과 임상 맥락</a:t>
             </a:r>
             <a:r>
               <a:rPr sz="1400" b="0" i="0">
@@ -7457,7 +7469,7 @@
                 <a:ea typeface="Malgun Gothic"/>
                 <a:cs typeface="Malgun Gothic"/>
               </a:rPr>
-              <a:t> 기질은 만들어지는데 칼슘과 인이 침착되지 않는 경우다. 구루병과 골연화증이며, 원인은 vitamin D 결핍, 인 소실, 신장 질환으로 나뉜다. 검사에서 alkaline phosphatase가 오른다.</a:t>
+              <a:t>이다. 골밀도는 양만 알려 주고 질을 알려 주지 않으며, 무기질화 이상에서는 오히려 오해를 부를 수 있다. 골연화증에서 골밀도가 낮게 나오지만 필요한 치료는 골흡수 억제제가 아니라 vitamin D와 인의 보충이다. 흡수 억제제를 잘못 쓰면 무기질화되지 않은 기질이 더 쌓여 악화된다.</a:t>
             </a:r>
           </a:p>
           <a:p>
@@ -7486,7 +7498,7 @@
                 <a:ea typeface="Malgun Gothic"/>
                 <a:cs typeface="Malgun Gothic"/>
               </a:rPr>
-              <a:t>3. 재형성의 균형이 문제인가.</a:t>
+              <a:t>2. 무기질화가 문제인가.</a:t>
             </a:r>
             <a:r>
               <a:rPr sz="1400" b="0" i="0">
@@ -7497,7 +7509,7 @@
                 <a:ea typeface="Malgun Gothic"/>
                 <a:cs typeface="Malgun Gothic"/>
               </a:rPr>
-              <a:t> 양은 정상적으로 무기질화되었으나 전체 양이 줄거나 늘어난 경우다.</a:t>
+              <a:t> 기질은 만들어지는데 칼슘과 인이 침착되지 않는 경우다. 구루병과 골연화증이며, 원인은 vitamin D 결핍, 인 소실, 신장 질환으로 나뉜다. 검사에서 alkaline phosphatase가 오른다.</a:t>
             </a:r>
           </a:p>
           <a:p>
@@ -7518,6 +7530,17 @@
               <a:t>•  </a:t>
             </a:r>
             <a:r>
+              <a:rPr sz="1400" b="1" i="0">
+                <a:solidFill>
+                  <a:srgbClr val="11202B"/>
+                </a:solidFill>
+                <a:latin typeface="Malgun Gothic"/>
+                <a:ea typeface="Malgun Gothic"/>
+                <a:cs typeface="Malgun Gothic"/>
+              </a:rPr>
+              <a:t>골다공증의 위험 요인도 기전으로 묶인다.</a:t>
+            </a:r>
+            <a:r>
               <a:rPr sz="1400" b="0" i="0">
                 <a:solidFill>
                   <a:srgbClr val="11202B"/>
@@ -7526,7 +7549,7 @@
                 <a:ea typeface="Malgun Gothic"/>
                 <a:cs typeface="Malgun Gothic"/>
               </a:rPr>
-              <a:t>흡수 &gt; 형성: </a:t>
+              <a:t> 폐경은 estrogen 감소로 RANKL 쪽을 우세하게 만들고, 고령은 osteoblast의 기능과 vitamin D 활성화 능력을 함께 떨어뜨린다. Glucocorticoid는 osteoblast의 분화와 생존을 억제하고 장의 칼슘 흡수를 줄여 가장 흔한 이차성 골다공증의 원인이 된다. 부동은 10절의 기계적 신호를 없앤다. 흡연과 과도한 음주, 저체중, 영양 부족이 더해진다. 위험 요인을 외우는 대신 </a:t>
             </a:r>
             <a:r>
               <a:rPr sz="1400" b="1" i="0">
@@ -7537,7 +7560,7 @@
                 <a:ea typeface="Malgun Gothic"/>
                 <a:cs typeface="Malgun Gothic"/>
               </a:rPr>
-              <a:t>골다공증</a:t>
+              <a:t>어느 경로를 건드리는지</a:t>
             </a:r>
             <a:r>
               <a:rPr sz="1400" b="0" i="0">
@@ -7548,7 +7571,7 @@
                 <a:ea typeface="Malgun Gothic"/>
                 <a:cs typeface="Malgun Gothic"/>
               </a:rPr>
-              <a:t>. 폐경, 고령, glucocorticoid, 부동이 원인이다.</a:t>
+              <a:t>로 분류하면 치료와 예방의 방향도 함께 정해진다.</a:t>
             </a:r>
           </a:p>
           <a:p>
@@ -7569,6 +7592,17 @@
               <a:t>•  </a:t>
             </a:r>
             <a:r>
+              <a:rPr sz="1400" b="1" i="0">
+                <a:solidFill>
+                  <a:srgbClr val="11202B"/>
+                </a:solidFill>
+                <a:latin typeface="Malgun Gothic"/>
+                <a:ea typeface="Malgun Gothic"/>
+                <a:cs typeface="Malgun Gothic"/>
+              </a:rPr>
+              <a:t>3. 재형성의 균형이 문제인가.</a:t>
+            </a:r>
+            <a:r>
               <a:rPr sz="1400" b="0" i="0">
                 <a:solidFill>
                   <a:srgbClr val="11202B"/>
@@ -7577,51 +7611,7 @@
                 <a:ea typeface="Malgun Gothic"/>
                 <a:cs typeface="Malgun Gothic"/>
               </a:rPr>
-              <a:t>흡수 &lt; 형성(또는 형성이 무질서): </a:t>
-            </a:r>
-            <a:r>
-              <a:rPr sz="1400" b="1" i="0">
-                <a:solidFill>
-                  <a:srgbClr val="11202B"/>
-                </a:solidFill>
-                <a:latin typeface="Malgun Gothic"/>
-                <a:ea typeface="Malgun Gothic"/>
-                <a:cs typeface="Malgun Gothic"/>
-              </a:rPr>
-              <a:t>골화석증</a:t>
-            </a:r>
-            <a:r>
-              <a:rPr sz="1400" b="0" i="0">
-                <a:solidFill>
-                  <a:srgbClr val="11202B"/>
-                </a:solidFill>
-                <a:latin typeface="Malgun Gothic"/>
-                <a:ea typeface="Malgun Gothic"/>
-                <a:cs typeface="Malgun Gothic"/>
-              </a:rPr>
-              <a:t>(흡수 불가), </a:t>
-            </a:r>
-            <a:r>
-              <a:rPr sz="1400" b="1" i="0">
-                <a:solidFill>
-                  <a:srgbClr val="11202B"/>
-                </a:solidFill>
-                <a:latin typeface="Malgun Gothic"/>
-                <a:ea typeface="Malgun Gothic"/>
-                <a:cs typeface="Malgun Gothic"/>
-              </a:rPr>
-              <a:t>Paget 병</a:t>
-            </a:r>
-            <a:r>
-              <a:rPr sz="1400" b="0" i="0">
-                <a:solidFill>
-                  <a:srgbClr val="11202B"/>
-                </a:solidFill>
-                <a:latin typeface="Malgun Gothic"/>
-                <a:ea typeface="Malgun Gothic"/>
-                <a:cs typeface="Malgun Gothic"/>
-              </a:rPr>
-              <a:t>(둘 다 폭주하며 구조가 무질서).</a:t>
+              <a:t> 양은 정상적으로 무기질화되었으나 전체 양이 줄거나 늘어난 경우다.</a:t>
             </a:r>
           </a:p>
           <a:p>
@@ -7642,6 +7632,17 @@
               <a:t>•  </a:t>
             </a:r>
             <a:r>
+              <a:rPr sz="1400" b="0" i="0">
+                <a:solidFill>
+                  <a:srgbClr val="11202B"/>
+                </a:solidFill>
+                <a:latin typeface="Malgun Gothic"/>
+                <a:ea typeface="Malgun Gothic"/>
+                <a:cs typeface="Malgun Gothic"/>
+              </a:rPr>
+              <a:t>흡수 &gt; 형성: </a:t>
+            </a:r>
+            <a:r>
               <a:rPr sz="1400" b="1" i="0">
                 <a:solidFill>
                   <a:srgbClr val="11202B"/>
@@ -7650,7 +7651,7 @@
                 <a:ea typeface="Malgun Gothic"/>
                 <a:cs typeface="Malgun Gothic"/>
               </a:rPr>
-              <a:t>4. 연골과 윤활막이 문제인가.</a:t>
+              <a:t>골다공증</a:t>
             </a:r>
             <a:r>
               <a:rPr sz="1400" b="0" i="0">
@@ -7661,7 +7662,7 @@
                 <a:ea typeface="Malgun Gothic"/>
                 <a:cs typeface="Malgun Gothic"/>
               </a:rPr>
-              <a:t> 골관절염과 염증성 관절염이다.</a:t>
+              <a:t>. 폐경, 고령, glucocorticoid, 부동이 원인이다.</a:t>
             </a:r>
           </a:p>
           <a:p>
@@ -7682,6 +7683,17 @@
               <a:t>•  </a:t>
             </a:r>
             <a:r>
+              <a:rPr sz="1400" b="0" i="0">
+                <a:solidFill>
+                  <a:srgbClr val="11202B"/>
+                </a:solidFill>
+                <a:latin typeface="Malgun Gothic"/>
+                <a:ea typeface="Malgun Gothic"/>
+                <a:cs typeface="Malgun Gothic"/>
+              </a:rPr>
+              <a:t>흡수 &lt; 형성(또는 형성이 무질서): </a:t>
+            </a:r>
+            <a:r>
               <a:rPr sz="1400" b="1" i="0">
                 <a:solidFill>
                   <a:srgbClr val="11202B"/>
@@ -7690,7 +7702,7 @@
                 <a:ea typeface="Malgun Gothic"/>
                 <a:cs typeface="Malgun Gothic"/>
               </a:rPr>
-              <a:t>골절의 치유</a:t>
+              <a:t>골화석증</a:t>
             </a:r>
             <a:r>
               <a:rPr sz="1400" b="0" i="0">
@@ -7701,7 +7713,29 @@
                 <a:ea typeface="Malgun Gothic"/>
                 <a:cs typeface="Malgun Gothic"/>
               </a:rPr>
-              <a:t>도 앞의 구조를 따른다. 혈종 형성 → 염증 세포와 혈관의 침입 → 연골성 가골 형성 → 뼈로 치환(연골내골화와 같은 과정) → 재형성으로 원래 모양에 가깝게 정리. 치유가 지연되는 조건이 그대로 예측된다. 혈액 공급이 나쁘거나(개방 골절, 특정 부위), 안정되지 않거나(고정 실패), 감염이 있거나, 전신 요인(흡연, 당뇨, 영양 부족, 일부 약물)이 있으면 늦어진다.</a:t>
+              <a:t>(흡수 불가), </a:t>
+            </a:r>
+            <a:r>
+              <a:rPr sz="1400" b="1" i="0">
+                <a:solidFill>
+                  <a:srgbClr val="11202B"/>
+                </a:solidFill>
+                <a:latin typeface="Malgun Gothic"/>
+                <a:ea typeface="Malgun Gothic"/>
+                <a:cs typeface="Malgun Gothic"/>
+              </a:rPr>
+              <a:t>Paget 병</a:t>
+            </a:r>
+            <a:r>
+              <a:rPr sz="1400" b="0" i="0">
+                <a:solidFill>
+                  <a:srgbClr val="11202B"/>
+                </a:solidFill>
+                <a:latin typeface="Malgun Gothic"/>
+                <a:ea typeface="Malgun Gothic"/>
+                <a:cs typeface="Malgun Gothic"/>
+              </a:rPr>
+              <a:t>(둘 다 폭주하며 구조가 무질서).</a:t>
             </a:r>
           </a:p>
           <a:p>
@@ -7730,7 +7764,7 @@
                 <a:ea typeface="Malgun Gothic"/>
                 <a:cs typeface="Malgun Gothic"/>
               </a:rPr>
-              <a:t>치유의 두 방식.</a:t>
+              <a:t>4. 연골과 윤활막이 문제인가.</a:t>
             </a:r>
             <a:r>
               <a:rPr sz="1400" b="0" i="0">
@@ -7741,51 +7775,7 @@
                 <a:ea typeface="Malgun Gothic"/>
                 <a:cs typeface="Malgun Gothic"/>
               </a:rPr>
-              <a:t> 골절이 어떻게 고정되었는지에 따라 치유 방식이 달라진다. 틈이 남고 약간의 움직임이 있으면 위에서 본 대로 가골을 거치는 </a:t>
-            </a:r>
-            <a:r>
-              <a:rPr sz="1400" b="1" i="0">
-                <a:solidFill>
-                  <a:srgbClr val="11202B"/>
-                </a:solidFill>
-                <a:latin typeface="Malgun Gothic"/>
-                <a:ea typeface="Malgun Gothic"/>
-                <a:cs typeface="Malgun Gothic"/>
-              </a:rPr>
-              <a:t>이차 치유</a:t>
-            </a:r>
-            <a:r>
-              <a:rPr sz="1400" b="0" i="0">
-                <a:solidFill>
-                  <a:srgbClr val="11202B"/>
-                </a:solidFill>
-                <a:latin typeface="Malgun Gothic"/>
-                <a:ea typeface="Malgun Gothic"/>
-                <a:cs typeface="Malgun Gothic"/>
-              </a:rPr>
-              <a:t>가 일어난다. 반면 수술로 골절면을 완벽히 맞추고 압박해 고정하면 가골 없이 osteon이 골절선을 가로질러 직접 자라는 </a:t>
-            </a:r>
-            <a:r>
-              <a:rPr sz="1400" b="1" i="0">
-                <a:solidFill>
-                  <a:srgbClr val="11202B"/>
-                </a:solidFill>
-                <a:latin typeface="Malgun Gothic"/>
-                <a:ea typeface="Malgun Gothic"/>
-                <a:cs typeface="Malgun Gothic"/>
-              </a:rPr>
-              <a:t>일차 치유</a:t>
-            </a:r>
-            <a:r>
-              <a:rPr sz="1400" b="0" i="0">
-                <a:solidFill>
-                  <a:srgbClr val="11202B"/>
-                </a:solidFill>
-                <a:latin typeface="Malgun Gothic"/>
-                <a:ea typeface="Malgun Gothic"/>
-                <a:cs typeface="Malgun Gothic"/>
-              </a:rPr>
-              <a:t>가 일어난다. 일차 치유는 가골이 생기지 않으므로 방사선에서 치유의 진행이 잘 보이지 않고, 고정이 조금이라도 불안정하면 실패한다. 어느 쪽을 목표로 하는지에 따라 수술 방법과 경과 판단의 기준이 달라진다.</a:t>
+              <a:t> 골관절염과 염증성 관절염이다. 연골은 재생되지 않으므로 치료의 목표가 복구가 아니라 진행의 지연과 증상 조절에 놓인다는 점에서 앞의 세 범주와 성격이 다르다.</a:t>
             </a:r>
           </a:p>
           <a:p>
@@ -7814,7 +7804,7 @@
                 <a:ea typeface="Malgun Gothic"/>
                 <a:cs typeface="Malgun Gothic"/>
               </a:rPr>
-              <a:t>골절의 부위가 예후를 정하는 예.</a:t>
+              <a:t>골절의 치유</a:t>
             </a:r>
             <a:r>
               <a:rPr sz="1400" b="0" i="0">
@@ -7825,29 +7815,7 @@
                 <a:ea typeface="Malgun Gothic"/>
                 <a:cs typeface="Malgun Gothic"/>
               </a:rPr>
-              <a:t> 넙다리뼈 목, 손배뼈, 발목뼈의 일부는 혈액 공급이 한 방향에서만 들어오므로, 골절선이 혈관을 끊으면 </a:t>
-            </a:r>
-            <a:r>
-              <a:rPr sz="1400" b="1" i="0">
-                <a:solidFill>
-                  <a:srgbClr val="11202B"/>
-                </a:solidFill>
-                <a:latin typeface="Malgun Gothic"/>
-                <a:ea typeface="Malgun Gothic"/>
-                <a:cs typeface="Malgun Gothic"/>
-              </a:rPr>
-              <a:t>무혈성 괴사</a:t>
-            </a:r>
-            <a:r>
-              <a:rPr sz="1400" b="0" i="0">
-                <a:solidFill>
-                  <a:srgbClr val="11202B"/>
-                </a:solidFill>
-                <a:latin typeface="Malgun Gothic"/>
-                <a:ea typeface="Malgun Gothic"/>
-                <a:cs typeface="Malgun Gothic"/>
-              </a:rPr>
-              <a:t>가 생긴다. 해부학적 혈액 공급을 아는 것이 예후 판단의 근거가 된다.</a:t>
+              <a:t>도 앞의 구조를 따른다. 혈종 형성 → 염증 세포와 혈관의 침입 → 연골성 가골 형성 → 뼈로 치환(연골내골화와 같은 과정) → 재형성으로 원래 모양에 가깝게 정리. 치유가 지연되는 조건이 그대로 예측된다. 혈액 공급이 나쁘거나(개방 골절, 특정 부위), 안정되지 않거나(고정 실패), 감염이 있거나, 전신 요인(흡연, 당뇨, 영양 부족, 일부 약물)이 있으면 늦어진다.</a:t>
             </a:r>
           </a:p>
         </p:txBody>
@@ -8033,7 +8001,7 @@
                 <a:ea typeface="Malgun Gothic"/>
                 <a:cs typeface="Malgun Gothic"/>
               </a:rPr>
-              <a:t>15   </a:t>
+              <a:t>14   </a:t>
             </a:r>
             <a:r>
               <a:rPr sz="2400" b="1" i="0">
@@ -8044,7 +8012,7 @@
                 <a:ea typeface="Malgun Gothic"/>
                 <a:cs typeface="Malgun Gothic"/>
               </a:rPr>
-              <a:t>15. 이 수업이 이어지는 곳</a:t>
+              <a:t>14. 뼈와 관절 질환을 읽는 논리 (2/2)</a:t>
             </a:r>
           </a:p>
         </p:txBody>
@@ -8124,7 +8092,7 @@
               </a:spcAft>
             </a:pPr>
             <a:r>
-              <a:rPr sz="1600" b="1" i="0">
+              <a:rPr sz="1800" b="1" i="0">
                 <a:solidFill>
                   <a:srgbClr val="F2B705"/>
                 </a:solidFill>
@@ -8135,26 +8103,70 @@
               <a:t>•  </a:t>
             </a:r>
             <a:r>
-              <a:rPr sz="1600" b="1" i="0">
-                <a:solidFill>
-                  <a:srgbClr val="11202B"/>
-                </a:solidFill>
-                <a:latin typeface="Malgun Gothic"/>
-                <a:ea typeface="Malgun Gothic"/>
-                <a:cs typeface="Malgun Gothic"/>
-              </a:rPr>
-              <a:t>칼슘과 인의 전신 조절, PTH와 vitamin D, FGF23</a:t>
-            </a:r>
-            <a:r>
-              <a:rPr sz="1600" b="0" i="0">
-                <a:solidFill>
-                  <a:srgbClr val="11202B"/>
-                </a:solidFill>
-                <a:latin typeface="Malgun Gothic"/>
-                <a:ea typeface="Malgun Gothic"/>
-                <a:cs typeface="Malgun Gothic"/>
-              </a:rPr>
-              <a:t>: M01-W02-L02에서 다루었다. 만성 신질환의 뼈–무기질 이상은 M01-W02-L01에서 다루었다.</a:t>
+              <a:rPr sz="1800" b="1" i="0">
+                <a:solidFill>
+                  <a:srgbClr val="11202B"/>
+                </a:solidFill>
+                <a:latin typeface="Malgun Gothic"/>
+                <a:ea typeface="Malgun Gothic"/>
+                <a:cs typeface="Malgun Gothic"/>
+              </a:rPr>
+              <a:t>치유의 두 방식.</a:t>
+            </a:r>
+            <a:r>
+              <a:rPr sz="1800" b="0" i="0">
+                <a:solidFill>
+                  <a:srgbClr val="11202B"/>
+                </a:solidFill>
+                <a:latin typeface="Malgun Gothic"/>
+                <a:ea typeface="Malgun Gothic"/>
+                <a:cs typeface="Malgun Gothic"/>
+              </a:rPr>
+              <a:t> 골절이 어떻게 고정되었는지에 따라 치유 방식이 달라진다. 틈이 남고 약간의 움직임이 있으면 위에서 본 대로 가골을 거치는 </a:t>
+            </a:r>
+            <a:r>
+              <a:rPr sz="1800" b="1" i="0">
+                <a:solidFill>
+                  <a:srgbClr val="11202B"/>
+                </a:solidFill>
+                <a:latin typeface="Malgun Gothic"/>
+                <a:ea typeface="Malgun Gothic"/>
+                <a:cs typeface="Malgun Gothic"/>
+              </a:rPr>
+              <a:t>이차 치유</a:t>
+            </a:r>
+            <a:r>
+              <a:rPr sz="1800" b="0" i="0">
+                <a:solidFill>
+                  <a:srgbClr val="11202B"/>
+                </a:solidFill>
+                <a:latin typeface="Malgun Gothic"/>
+                <a:ea typeface="Malgun Gothic"/>
+                <a:cs typeface="Malgun Gothic"/>
+              </a:rPr>
+              <a:t>가 일어난다. 반면 수술로 골절면을 완벽히 맞추고 압박해 고정하면 가골 없이 osteon이 골절선을 가로질러 직접 자라는 </a:t>
+            </a:r>
+            <a:r>
+              <a:rPr sz="1800" b="1" i="0">
+                <a:solidFill>
+                  <a:srgbClr val="11202B"/>
+                </a:solidFill>
+                <a:latin typeface="Malgun Gothic"/>
+                <a:ea typeface="Malgun Gothic"/>
+                <a:cs typeface="Malgun Gothic"/>
+              </a:rPr>
+              <a:t>일차 치유</a:t>
+            </a:r>
+            <a:r>
+              <a:rPr sz="1800" b="0" i="0">
+                <a:solidFill>
+                  <a:srgbClr val="11202B"/>
+                </a:solidFill>
+                <a:latin typeface="Malgun Gothic"/>
+                <a:ea typeface="Malgun Gothic"/>
+                <a:cs typeface="Malgun Gothic"/>
+              </a:rPr>
+              <a:t>가 일어난다. 일차 치유는 가골이 생기지 않으므로 방사선에서 치유의 진행이 잘 보이지 않고, 고정이 조금이라도 불안정하면 실패한다. 어느 쪽을 목표로 하는지에 따라 수술 방법과 경과 판단의 기준이 달라진다.</a:t>
             </a:r>
           </a:p>
           <a:p>
@@ -8164,7 +8176,7 @@
               </a:spcAft>
             </a:pPr>
             <a:r>
-              <a:rPr sz="1600" b="1" i="0">
+              <a:rPr sz="1800" b="1" i="0">
                 <a:solidFill>
                   <a:srgbClr val="F2B705"/>
                 </a:solidFill>
@@ -8175,226 +8187,48 @@
               <a:t>•  </a:t>
             </a:r>
             <a:r>
-              <a:rPr sz="1600" b="1" i="0">
-                <a:solidFill>
-                  <a:srgbClr val="11202B"/>
-                </a:solidFill>
-                <a:latin typeface="Malgun Gothic"/>
-                <a:ea typeface="Malgun Gothic"/>
-                <a:cs typeface="Malgun Gothic"/>
-              </a:rPr>
-              <a:t>collagen의 구조와 합성, 번역 후 수정</a:t>
-            </a:r>
-            <a:r>
-              <a:rPr sz="1600" b="0" i="0">
-                <a:solidFill>
-                  <a:srgbClr val="11202B"/>
-                </a:solidFill>
-                <a:latin typeface="Malgun Gothic"/>
-                <a:ea typeface="Malgun Gothic"/>
-                <a:cs typeface="Malgun Gothic"/>
-              </a:rPr>
-              <a:t>: M02-W02-L01에서 섬유성 단백질로 다룬다. Vitamin C가 collagen의 proline과 lysine을 hydroxylation하는 데 필요하다는 사실과 괴혈병의 기전이 여기서 설명된다.</a:t>
-            </a:r>
-          </a:p>
-          <a:p>
-            <a:pPr>
-              <a:spcAft>
-                <a:spcPts val="900"/>
-              </a:spcAft>
-            </a:pPr>
-            <a:r>
-              <a:rPr sz="1600" b="1" i="0">
-                <a:solidFill>
-                  <a:srgbClr val="F2B705"/>
-                </a:solidFill>
-                <a:latin typeface="Malgun Gothic"/>
-                <a:ea typeface="Malgun Gothic"/>
-                <a:cs typeface="Malgun Gothic"/>
-              </a:rPr>
-              <a:t>•  </a:t>
-            </a:r>
-            <a:r>
-              <a:rPr sz="1600" b="1" i="0">
-                <a:solidFill>
-                  <a:srgbClr val="11202B"/>
-                </a:solidFill>
-                <a:latin typeface="Malgun Gothic"/>
-                <a:ea typeface="Malgun Gothic"/>
-                <a:cs typeface="Malgun Gothic"/>
-              </a:rPr>
-              <a:t>세포외기질과 세포 접착</a:t>
-            </a:r>
-            <a:r>
-              <a:rPr sz="1600" b="0" i="0">
-                <a:solidFill>
-                  <a:srgbClr val="11202B"/>
-                </a:solidFill>
-                <a:latin typeface="Malgun Gothic"/>
-                <a:ea typeface="Malgun Gothic"/>
-                <a:cs typeface="Malgun Gothic"/>
-              </a:rPr>
-              <a:t>: M01-W11-L01에서 다룬다. 연골과 뼈 기질은 세포외기질의 특수한 형태다.</a:t>
-            </a:r>
-          </a:p>
-          <a:p>
-            <a:pPr>
-              <a:spcAft>
-                <a:spcPts val="900"/>
-              </a:spcAft>
-            </a:pPr>
-            <a:r>
-              <a:rPr sz="1600" b="1" i="0">
-                <a:solidFill>
-                  <a:srgbClr val="F2B705"/>
-                </a:solidFill>
-                <a:latin typeface="Malgun Gothic"/>
-                <a:ea typeface="Malgun Gothic"/>
-                <a:cs typeface="Malgun Gothic"/>
-              </a:rPr>
-              <a:t>•  </a:t>
-            </a:r>
-            <a:r>
-              <a:rPr sz="1600" b="1" i="0">
-                <a:solidFill>
-                  <a:srgbClr val="11202B"/>
-                </a:solidFill>
-                <a:latin typeface="Malgun Gothic"/>
-                <a:ea typeface="Malgun Gothic"/>
-                <a:cs typeface="Malgun Gothic"/>
-              </a:rPr>
-              <a:t>Wnt 신호 경로</a:t>
-            </a:r>
-            <a:r>
-              <a:rPr sz="1600" b="0" i="0">
-                <a:solidFill>
-                  <a:srgbClr val="11202B"/>
-                </a:solidFill>
-                <a:latin typeface="Malgun Gothic"/>
-                <a:ea typeface="Malgun Gothic"/>
-                <a:cs typeface="Malgun Gothic"/>
-              </a:rPr>
-              <a:t>: M01-W11-L02에서 다룬다. Sclerostin이 억제하는 경로다.</a:t>
-            </a:r>
-          </a:p>
-          <a:p>
-            <a:pPr>
-              <a:spcAft>
-                <a:spcPts val="900"/>
-              </a:spcAft>
-            </a:pPr>
-            <a:r>
-              <a:rPr sz="1600" b="1" i="0">
-                <a:solidFill>
-                  <a:srgbClr val="F2B705"/>
-                </a:solidFill>
-                <a:latin typeface="Malgun Gothic"/>
-                <a:ea typeface="Malgun Gothic"/>
-                <a:cs typeface="Malgun Gothic"/>
-              </a:rPr>
-              <a:t>•  </a:t>
-            </a:r>
-            <a:r>
-              <a:rPr sz="1600" b="1" i="0">
-                <a:solidFill>
-                  <a:srgbClr val="11202B"/>
-                </a:solidFill>
-                <a:latin typeface="Malgun Gothic"/>
-                <a:ea typeface="Malgun Gothic"/>
-                <a:cs typeface="Malgun Gothic"/>
-              </a:rPr>
-              <a:t>중간엽 줄기세포와 분화 운명 결정</a:t>
-            </a:r>
-            <a:r>
-              <a:rPr sz="1600" b="0" i="0">
-                <a:solidFill>
-                  <a:srgbClr val="11202B"/>
-                </a:solidFill>
-                <a:latin typeface="Malgun Gothic"/>
-                <a:ea typeface="Malgun Gothic"/>
-                <a:cs typeface="Malgun Gothic"/>
-              </a:rPr>
-              <a:t>: M01-W12-L02에서 다룬다.</a:t>
-            </a:r>
-          </a:p>
-          <a:p>
-            <a:pPr>
-              <a:spcAft>
-                <a:spcPts val="900"/>
-              </a:spcAft>
-            </a:pPr>
-            <a:r>
-              <a:rPr sz="1600" b="1" i="0">
-                <a:solidFill>
-                  <a:srgbClr val="F2B705"/>
-                </a:solidFill>
-                <a:latin typeface="Malgun Gothic"/>
-                <a:ea typeface="Malgun Gothic"/>
-                <a:cs typeface="Malgun Gothic"/>
-              </a:rPr>
-              <a:t>•  </a:t>
-            </a:r>
-            <a:r>
-              <a:rPr sz="1600" b="1" i="0">
-                <a:solidFill>
-                  <a:srgbClr val="11202B"/>
-                </a:solidFill>
-                <a:latin typeface="Malgun Gothic"/>
-                <a:ea typeface="Malgun Gothic"/>
-                <a:cs typeface="Malgun Gothic"/>
-              </a:rPr>
-              <a:t>파골세포의 기원인 단핵구 계통</a:t>
-            </a:r>
-            <a:r>
-              <a:rPr sz="1600" b="0" i="0">
-                <a:solidFill>
-                  <a:srgbClr val="11202B"/>
-                </a:solidFill>
-                <a:latin typeface="Malgun Gothic"/>
-                <a:ea typeface="Malgun Gothic"/>
-                <a:cs typeface="Malgun Gothic"/>
-              </a:rPr>
-              <a:t>: 혈액세포의 분화는 M01-W08-L02와 M05에서 다룬다.</a:t>
-            </a:r>
-          </a:p>
-          <a:p>
-            <a:pPr>
-              <a:spcAft>
-                <a:spcPts val="900"/>
-              </a:spcAft>
-            </a:pPr>
-            <a:r>
-              <a:rPr sz="1600" b="1" i="0">
-                <a:solidFill>
-                  <a:srgbClr val="F2B705"/>
-                </a:solidFill>
-                <a:latin typeface="Malgun Gothic"/>
-                <a:ea typeface="Malgun Gothic"/>
-                <a:cs typeface="Malgun Gothic"/>
-              </a:rPr>
-              <a:t>•  </a:t>
-            </a:r>
-            <a:r>
-              <a:rPr sz="1600" b="1" i="0">
-                <a:solidFill>
-                  <a:srgbClr val="11202B"/>
-                </a:solidFill>
-                <a:latin typeface="Malgun Gothic"/>
-                <a:ea typeface="Malgun Gothic"/>
-                <a:cs typeface="Malgun Gothic"/>
-              </a:rPr>
-              <a:t>사지와 체절의 발생</a:t>
-            </a:r>
-            <a:r>
-              <a:rPr sz="1600" b="0" i="0">
-                <a:solidFill>
-                  <a:srgbClr val="11202B"/>
-                </a:solidFill>
-                <a:latin typeface="Malgun Gothic"/>
-                <a:ea typeface="Malgun Gothic"/>
-                <a:cs typeface="Malgun Gothic"/>
-              </a:rPr>
-              <a:t>: M01-W03-L01에서 다루었다.</a:t>
+              <a:rPr sz="1800" b="1" i="0">
+                <a:solidFill>
+                  <a:srgbClr val="11202B"/>
+                </a:solidFill>
+                <a:latin typeface="Malgun Gothic"/>
+                <a:ea typeface="Malgun Gothic"/>
+                <a:cs typeface="Malgun Gothic"/>
+              </a:rPr>
+              <a:t>골절의 부위가 예후를 정하는 예.</a:t>
+            </a:r>
+            <a:r>
+              <a:rPr sz="1800" b="0" i="0">
+                <a:solidFill>
+                  <a:srgbClr val="11202B"/>
+                </a:solidFill>
+                <a:latin typeface="Malgun Gothic"/>
+                <a:ea typeface="Malgun Gothic"/>
+                <a:cs typeface="Malgun Gothic"/>
+              </a:rPr>
+              <a:t> 넙다리뼈 목, 손배뼈, 발목뼈의 일부는 혈액 공급이 한 방향에서만 들어오므로, 골절선이 혈관을 끊으면 </a:t>
+            </a:r>
+            <a:r>
+              <a:rPr sz="1800" b="1" i="0">
+                <a:solidFill>
+                  <a:srgbClr val="11202B"/>
+                </a:solidFill>
+                <a:latin typeface="Malgun Gothic"/>
+                <a:ea typeface="Malgun Gothic"/>
+                <a:cs typeface="Malgun Gothic"/>
+              </a:rPr>
+              <a:t>무혈성 괴사</a:t>
+            </a:r>
+            <a:r>
+              <a:rPr sz="1800" b="0" i="0">
+                <a:solidFill>
+                  <a:srgbClr val="11202B"/>
+                </a:solidFill>
+                <a:latin typeface="Malgun Gothic"/>
+                <a:ea typeface="Malgun Gothic"/>
+                <a:cs typeface="Malgun Gothic"/>
+              </a:rPr>
+              <a:t>가 생긴다. 해부학적 혈액 공급을 아는 것이 예후 판단의 근거가 된다.</a:t>
             </a:r>
           </a:p>
         </p:txBody>
@@ -8645,55 +8479,52 @@
       </p:sp>
       <p:sp>
         <p:nvSpPr>
-          <p:cNvPr id="7" name="Rectangle 6"/>
-          <p:cNvSpPr/>
-          <p:nvPr/>
-        </p:nvSpPr>
-        <p:spPr>
-          <a:xfrm>
-            <a:off x="640080" y="1325880"/>
-            <a:ext cx="10881360" cy="1386839"/>
-          </a:xfrm>
-          <a:prstGeom prst="rect">
-            <a:avLst/>
-          </a:prstGeom>
-          <a:solidFill>
-            <a:srgbClr val="FFF5D6"/>
-          </a:solidFill>
-          <a:ln>
-            <a:noFill/>
-          </a:ln>
-          <a:effectLst/>
-        </p:spPr>
-        <p:style>
-          <a:lnRef idx="1">
-            <a:schemeClr val="accent1"/>
-          </a:lnRef>
-          <a:fillRef idx="3">
-            <a:schemeClr val="accent1"/>
-          </a:fillRef>
-          <a:effectRef idx="2">
-            <a:schemeClr val="accent1"/>
-          </a:effectRef>
-          <a:fontRef idx="minor">
-            <a:schemeClr val="lt1"/>
-          </a:fontRef>
-        </p:style>
-        <p:txBody>
-          <a:bodyPr rtlCol="0" anchor="ctr" wrap="square" lIns="228600" rIns="228600"/>
-          <a:lstStyle/>
-          <a:p>
-            <a:pPr algn="l"/>
-            <a:r>
-              <a:rPr sz="1200" b="1" i="0">
-                <a:solidFill>
-                  <a:srgbClr val="8A6300"/>
-                </a:solidFill>
-                <a:latin typeface="Malgun Gothic"/>
-                <a:ea typeface="Malgun Gothic"/>
-                <a:cs typeface="Malgun Gothic"/>
-              </a:rPr>
-              <a:t>핵심 정리   </a:t>
+          <p:cNvPr id="7" name="TextBox 6"/>
+          <p:cNvSpPr txBox="1"/>
+          <p:nvPr/>
+        </p:nvSpPr>
+        <p:spPr>
+          <a:xfrm>
+            <a:off x="640080" y="1280160"/>
+            <a:ext cx="10881360" cy="5029200"/>
+          </a:xfrm>
+          <a:prstGeom prst="rect">
+            <a:avLst/>
+          </a:prstGeom>
+          <a:noFill/>
+        </p:spPr>
+        <p:txBody>
+          <a:bodyPr wrap="square" anchor="t">
+            <a:spAutoFit/>
+          </a:bodyPr>
+          <a:lstStyle/>
+          <a:p>
+            <a:pPr>
+              <a:spcAft>
+                <a:spcPts val="900"/>
+              </a:spcAft>
+            </a:pPr>
+            <a:r>
+              <a:rPr sz="1600" b="1" i="0">
+                <a:solidFill>
+                  <a:srgbClr val="F2B705"/>
+                </a:solidFill>
+                <a:latin typeface="Malgun Gothic"/>
+                <a:ea typeface="Malgun Gothic"/>
+                <a:cs typeface="Malgun Gothic"/>
+              </a:rPr>
+              <a:t>•  </a:t>
+            </a:r>
+            <a:r>
+              <a:rPr sz="1600" b="1" i="0">
+                <a:solidFill>
+                  <a:srgbClr val="11202B"/>
+                </a:solidFill>
+                <a:latin typeface="Malgun Gothic"/>
+                <a:ea typeface="Malgun Gothic"/>
+                <a:cs typeface="Malgun Gothic"/>
+              </a:rPr>
+              <a:t>칼슘과 인의 전신 조절, PTH와 vitamin D, FGF23</a:t>
             </a:r>
             <a:r>
               <a:rPr sz="1600" b="0" i="0">
@@ -8704,18 +8535,36 @@
                 <a:ea typeface="Malgun Gothic"/>
                 <a:cs typeface="Malgun Gothic"/>
               </a:rPr>
-              <a:t>뼈를 하나의 문장으로 요약하면 이렇다. </a:t>
-            </a:r>
+              <a:t>: M01-W02-L02에서 다루었다. 만성 신질환의 뼈–무기질 이상은 M01-W02-L01에서 다루었다.</a:t>
+            </a:r>
+          </a:p>
+          <a:p>
+            <a:pPr>
+              <a:spcAft>
+                <a:spcPts val="900"/>
+              </a:spcAft>
+            </a:pPr>
             <a:r>
               <a:rPr sz="1600" b="1" i="0">
                 <a:solidFill>
-                  <a:srgbClr val="11202B"/>
-                </a:solidFill>
-                <a:latin typeface="Malgun Gothic"/>
-                <a:ea typeface="Malgun Gothic"/>
-                <a:cs typeface="Malgun Gothic"/>
-              </a:rPr>
-              <a:t>뼈는 두 성분의 복합 재료이고, 네 세포가 지휘 관계를 이루며 끊임없이 허물고 다시 짓는 대사 조직이며, 받는 힘에 맞추어 구조를 바꾼다.</a:t>
+                  <a:srgbClr val="F2B705"/>
+                </a:solidFill>
+                <a:latin typeface="Malgun Gothic"/>
+                <a:ea typeface="Malgun Gothic"/>
+                <a:cs typeface="Malgun Gothic"/>
+              </a:rPr>
+              <a:t>•  </a:t>
+            </a:r>
+            <a:r>
+              <a:rPr sz="1600" b="1" i="0">
+                <a:solidFill>
+                  <a:srgbClr val="11202B"/>
+                </a:solidFill>
+                <a:latin typeface="Malgun Gothic"/>
+                <a:ea typeface="Malgun Gothic"/>
+                <a:cs typeface="Malgun Gothic"/>
+              </a:rPr>
+              <a:t>collagen의 구조와 합성, 번역 후 수정</a:t>
             </a:r>
             <a:r>
               <a:rPr sz="1600" b="0" i="0">
@@ -8726,7 +8575,207 @@
                 <a:ea typeface="Malgun Gothic"/>
                 <a:cs typeface="Malgun Gothic"/>
               </a:rPr>
-              <a:t> 이 세 가지를 쥐고 있으면 대사성 뼈 질환, 골다공증 치료제, 골절 치유, 부동에 의한 골소실이 모두 같은 틀 안에서 설명된다.</a:t>
+              <a:t>: M02-W02-L01에서 섬유성 단백질로 다룬다. Vitamin C가 collagen의 proline과 lysine을 hydroxylation하는 데 필요하다는 사실과 괴혈병의 기전이 여기서 설명된다.</a:t>
+            </a:r>
+          </a:p>
+          <a:p>
+            <a:pPr>
+              <a:spcAft>
+                <a:spcPts val="900"/>
+              </a:spcAft>
+            </a:pPr>
+            <a:r>
+              <a:rPr sz="1600" b="1" i="0">
+                <a:solidFill>
+                  <a:srgbClr val="F2B705"/>
+                </a:solidFill>
+                <a:latin typeface="Malgun Gothic"/>
+                <a:ea typeface="Malgun Gothic"/>
+                <a:cs typeface="Malgun Gothic"/>
+              </a:rPr>
+              <a:t>•  </a:t>
+            </a:r>
+            <a:r>
+              <a:rPr sz="1600" b="1" i="0">
+                <a:solidFill>
+                  <a:srgbClr val="11202B"/>
+                </a:solidFill>
+                <a:latin typeface="Malgun Gothic"/>
+                <a:ea typeface="Malgun Gothic"/>
+                <a:cs typeface="Malgun Gothic"/>
+              </a:rPr>
+              <a:t>세포외기질과 세포 접착</a:t>
+            </a:r>
+            <a:r>
+              <a:rPr sz="1600" b="0" i="0">
+                <a:solidFill>
+                  <a:srgbClr val="11202B"/>
+                </a:solidFill>
+                <a:latin typeface="Malgun Gothic"/>
+                <a:ea typeface="Malgun Gothic"/>
+                <a:cs typeface="Malgun Gothic"/>
+              </a:rPr>
+              <a:t>: M01-W11-L01에서 다룬다. 연골과 뼈 기질은 세포외기질의 특수한 형태다.</a:t>
+            </a:r>
+          </a:p>
+          <a:p>
+            <a:pPr>
+              <a:spcAft>
+                <a:spcPts val="900"/>
+              </a:spcAft>
+            </a:pPr>
+            <a:r>
+              <a:rPr sz="1600" b="1" i="0">
+                <a:solidFill>
+                  <a:srgbClr val="F2B705"/>
+                </a:solidFill>
+                <a:latin typeface="Malgun Gothic"/>
+                <a:ea typeface="Malgun Gothic"/>
+                <a:cs typeface="Malgun Gothic"/>
+              </a:rPr>
+              <a:t>•  </a:t>
+            </a:r>
+            <a:r>
+              <a:rPr sz="1600" b="1" i="0">
+                <a:solidFill>
+                  <a:srgbClr val="11202B"/>
+                </a:solidFill>
+                <a:latin typeface="Malgun Gothic"/>
+                <a:ea typeface="Malgun Gothic"/>
+                <a:cs typeface="Malgun Gothic"/>
+              </a:rPr>
+              <a:t>Wnt 신호 경로</a:t>
+            </a:r>
+            <a:r>
+              <a:rPr sz="1600" b="0" i="0">
+                <a:solidFill>
+                  <a:srgbClr val="11202B"/>
+                </a:solidFill>
+                <a:latin typeface="Malgun Gothic"/>
+                <a:ea typeface="Malgun Gothic"/>
+                <a:cs typeface="Malgun Gothic"/>
+              </a:rPr>
+              <a:t>: M01-W11-L02에서 다룬다. Sclerostin이 억제하는 경로다.</a:t>
+            </a:r>
+          </a:p>
+          <a:p>
+            <a:pPr>
+              <a:spcAft>
+                <a:spcPts val="900"/>
+              </a:spcAft>
+            </a:pPr>
+            <a:r>
+              <a:rPr sz="1600" b="1" i="0">
+                <a:solidFill>
+                  <a:srgbClr val="F2B705"/>
+                </a:solidFill>
+                <a:latin typeface="Malgun Gothic"/>
+                <a:ea typeface="Malgun Gothic"/>
+                <a:cs typeface="Malgun Gothic"/>
+              </a:rPr>
+              <a:t>•  </a:t>
+            </a:r>
+            <a:r>
+              <a:rPr sz="1600" b="1" i="0">
+                <a:solidFill>
+                  <a:srgbClr val="11202B"/>
+                </a:solidFill>
+                <a:latin typeface="Malgun Gothic"/>
+                <a:ea typeface="Malgun Gothic"/>
+                <a:cs typeface="Malgun Gothic"/>
+              </a:rPr>
+              <a:t>중간엽 줄기세포와 분화 운명 결정</a:t>
+            </a:r>
+            <a:r>
+              <a:rPr sz="1600" b="0" i="0">
+                <a:solidFill>
+                  <a:srgbClr val="11202B"/>
+                </a:solidFill>
+                <a:latin typeface="Malgun Gothic"/>
+                <a:ea typeface="Malgun Gothic"/>
+                <a:cs typeface="Malgun Gothic"/>
+              </a:rPr>
+              <a:t>: M01-W12-L02에서 다룬다.</a:t>
+            </a:r>
+          </a:p>
+          <a:p>
+            <a:pPr>
+              <a:spcAft>
+                <a:spcPts val="900"/>
+              </a:spcAft>
+            </a:pPr>
+            <a:r>
+              <a:rPr sz="1600" b="1" i="0">
+                <a:solidFill>
+                  <a:srgbClr val="F2B705"/>
+                </a:solidFill>
+                <a:latin typeface="Malgun Gothic"/>
+                <a:ea typeface="Malgun Gothic"/>
+                <a:cs typeface="Malgun Gothic"/>
+              </a:rPr>
+              <a:t>•  </a:t>
+            </a:r>
+            <a:r>
+              <a:rPr sz="1600" b="1" i="0">
+                <a:solidFill>
+                  <a:srgbClr val="11202B"/>
+                </a:solidFill>
+                <a:latin typeface="Malgun Gothic"/>
+                <a:ea typeface="Malgun Gothic"/>
+                <a:cs typeface="Malgun Gothic"/>
+              </a:rPr>
+              <a:t>파골세포의 기원인 단핵구 계통</a:t>
+            </a:r>
+            <a:r>
+              <a:rPr sz="1600" b="0" i="0">
+                <a:solidFill>
+                  <a:srgbClr val="11202B"/>
+                </a:solidFill>
+                <a:latin typeface="Malgun Gothic"/>
+                <a:ea typeface="Malgun Gothic"/>
+                <a:cs typeface="Malgun Gothic"/>
+              </a:rPr>
+              <a:t>: 혈액세포의 분화는 M01-W08-L02와 M05에서 다룬다.</a:t>
+            </a:r>
+          </a:p>
+          <a:p>
+            <a:pPr>
+              <a:spcAft>
+                <a:spcPts val="900"/>
+              </a:spcAft>
+            </a:pPr>
+            <a:r>
+              <a:rPr sz="1600" b="1" i="0">
+                <a:solidFill>
+                  <a:srgbClr val="F2B705"/>
+                </a:solidFill>
+                <a:latin typeface="Malgun Gothic"/>
+                <a:ea typeface="Malgun Gothic"/>
+                <a:cs typeface="Malgun Gothic"/>
+              </a:rPr>
+              <a:t>•  </a:t>
+            </a:r>
+            <a:r>
+              <a:rPr sz="1600" b="1" i="0">
+                <a:solidFill>
+                  <a:srgbClr val="11202B"/>
+                </a:solidFill>
+                <a:latin typeface="Malgun Gothic"/>
+                <a:ea typeface="Malgun Gothic"/>
+                <a:cs typeface="Malgun Gothic"/>
+              </a:rPr>
+              <a:t>사지와 체절의 발생</a:t>
+            </a:r>
+            <a:r>
+              <a:rPr sz="1600" b="0" i="0">
+                <a:solidFill>
+                  <a:srgbClr val="11202B"/>
+                </a:solidFill>
+                <a:latin typeface="Malgun Gothic"/>
+                <a:ea typeface="Malgun Gothic"/>
+                <a:cs typeface="Malgun Gothic"/>
+              </a:rPr>
+              <a:t>: M01-W03-L01에서 다루었다.</a:t>
             </a:r>
           </a:p>
         </p:txBody>
@@ -8912,7 +8961,7 @@
                 <a:ea typeface="Malgun Gothic"/>
                 <a:cs typeface="Malgun Gothic"/>
               </a:rPr>
-              <a:t>Q1   </a:t>
+              <a:t>15   </a:t>
             </a:r>
             <a:r>
               <a:rPr sz="2400" b="1" i="0">
@@ -8923,7 +8972,7 @@
                 <a:ea typeface="Malgun Gothic"/>
                 <a:cs typeface="Malgun Gothic"/>
               </a:rPr>
-              <a:t>확인 문항</a:t>
+              <a:t>15. 이 수업이 이어지는 곳</a:t>
             </a:r>
           </a:p>
         </p:txBody>
@@ -8977,61 +9026,23 @@
       </p:sp>
       <p:sp>
         <p:nvSpPr>
-          <p:cNvPr id="7" name="TextBox 6"/>
-          <p:cNvSpPr txBox="1"/>
-          <p:nvPr/>
-        </p:nvSpPr>
-        <p:spPr>
-          <a:xfrm>
-            <a:off x="640080" y="1371600"/>
-            <a:ext cx="10881360" cy="2103120"/>
-          </a:xfrm>
-          <a:prstGeom prst="rect">
-            <a:avLst/>
-          </a:prstGeom>
-          <a:noFill/>
-        </p:spPr>
-        <p:txBody>
-          <a:bodyPr wrap="square" anchor="t">
-            <a:spAutoFit/>
-          </a:bodyPr>
-          <a:lstStyle/>
-          <a:p>
-            <a:r>
-              <a:rPr sz="1900" b="1" i="0">
-                <a:solidFill>
-                  <a:srgbClr val="11202B"/>
-                </a:solidFill>
-                <a:latin typeface="Malgun Gothic"/>
-                <a:ea typeface="Malgun Gothic"/>
-                <a:cs typeface="Malgun Gothic"/>
-              </a:rPr>
-              <a:t>뼈가 동시에 수행해야 하는 요구 가운데 서로 모순되는 것을 들고, 그 해결 방식을 설명하시오.</a:t>
-            </a:r>
-          </a:p>
-        </p:txBody>
-      </p:sp>
-      <p:sp>
-        <p:nvSpPr>
-          <p:cNvPr id="8" name="Rectangle 7"/>
+          <p:cNvPr id="7" name="Rectangle 6"/>
           <p:cNvSpPr/>
           <p:nvPr/>
         </p:nvSpPr>
         <p:spPr>
           <a:xfrm>
-            <a:off x="640080" y="3657600"/>
-            <a:ext cx="10881360" cy="2606040"/>
+            <a:off x="640080" y="1325880"/>
+            <a:ext cx="10881360" cy="1386839"/>
           </a:xfrm>
           <a:prstGeom prst="rect">
             <a:avLst/>
           </a:prstGeom>
           <a:solidFill>
-            <a:srgbClr val="FFFFFF"/>
+            <a:srgbClr val="FFF5D6"/>
           </a:solidFill>
           <a:ln>
-            <a:solidFill>
-              <a:srgbClr val="C2CDD6"/>
-            </a:solidFill>
+            <a:noFill/>
           </a:ln>
           <a:effectLst/>
         </p:spPr>
@@ -9050,31 +9061,53 @@
           </a:fontRef>
         </p:style>
         <p:txBody>
-          <a:bodyPr rtlCol="0" anchor="ctr" wrap="square" lIns="228600" rIns="228600" tIns="164592"/>
+          <a:bodyPr rtlCol="0" anchor="ctr" wrap="square" lIns="228600" rIns="228600"/>
           <a:lstStyle/>
           <a:p>
             <a:pPr algn="l"/>
             <a:r>
               <a:rPr sz="1200" b="1" i="0">
                 <a:solidFill>
-                  <a:srgbClr val="003C71"/>
-                </a:solidFill>
-                <a:latin typeface="Malgun Gothic"/>
-                <a:ea typeface="Malgun Gothic"/>
-                <a:cs typeface="Malgun Gothic"/>
-              </a:rPr>
-              <a:t>해설   </a:t>
-            </a:r>
-            <a:r>
-              <a:rPr sz="1500" b="0" i="0">
-                <a:solidFill>
-                  <a:srgbClr val="11202B"/>
-                </a:solidFill>
-                <a:latin typeface="Malgun Gothic"/>
-                <a:ea typeface="Malgun Gothic"/>
-                <a:cs typeface="Malgun Gothic"/>
-              </a:rPr>
-              <a:t>지지와 보호를 위해서는 단단하고 변하지 않아야 하지만, 무기질 저장소로서는 칼슘을 쉽게 꺼내 쓸 수 있어야 한다. 또 움직임의 비용을 줄이려면 가벼워야 한다. 뼈는 이를 끊임없이 허물고 다시 짓는 재형성으로 해결한다. 모양은 유지하면서 재료를 교체하므로 구조적 요구와 대사적 요구를 동시에 만족하며, 성인에서도 해마다 전체 골격의 약 10%가 교체된다. 가벼움은 재료를 중심축에서 먼 바깥에 배치한 관 구조와 힘의 방향을 따라 배열된 해면뼈 기둥으로 해결한다.</a:t>
+                  <a:srgbClr val="8A6300"/>
+                </a:solidFill>
+                <a:latin typeface="Malgun Gothic"/>
+                <a:ea typeface="Malgun Gothic"/>
+                <a:cs typeface="Malgun Gothic"/>
+              </a:rPr>
+              <a:t>핵심 정리   </a:t>
+            </a:r>
+            <a:r>
+              <a:rPr sz="1600" b="0" i="0">
+                <a:solidFill>
+                  <a:srgbClr val="11202B"/>
+                </a:solidFill>
+                <a:latin typeface="Malgun Gothic"/>
+                <a:ea typeface="Malgun Gothic"/>
+                <a:cs typeface="Malgun Gothic"/>
+              </a:rPr>
+              <a:t>뼈를 하나의 문장으로 요약하면 이렇다. </a:t>
+            </a:r>
+            <a:r>
+              <a:rPr sz="1600" b="1" i="0">
+                <a:solidFill>
+                  <a:srgbClr val="11202B"/>
+                </a:solidFill>
+                <a:latin typeface="Malgun Gothic"/>
+                <a:ea typeface="Malgun Gothic"/>
+                <a:cs typeface="Malgun Gothic"/>
+              </a:rPr>
+              <a:t>뼈는 두 성분의 복합 재료이고, 네 세포가 지휘 관계를 이루며 끊임없이 허물고 다시 짓는 대사 조직이며, 받는 힘에 맞추어 구조를 바꾼다.</a:t>
+            </a:r>
+            <a:r>
+              <a:rPr sz="1600" b="0" i="0">
+                <a:solidFill>
+                  <a:srgbClr val="11202B"/>
+                </a:solidFill>
+                <a:latin typeface="Malgun Gothic"/>
+                <a:ea typeface="Malgun Gothic"/>
+                <a:cs typeface="Malgun Gothic"/>
+              </a:rPr>
+              <a:t> 이 세 가지를 쥐고 있으면 대사성 뼈 질환, 골다공증 치료제, 골절 치유, 부동에 의한 골소실이 모두 같은 틀 안에서 설명된다.</a:t>
             </a:r>
           </a:p>
         </p:txBody>
@@ -9260,7 +9293,7 @@
                 <a:ea typeface="Malgun Gothic"/>
                 <a:cs typeface="Malgun Gothic"/>
               </a:rPr>
-              <a:t>Q2   </a:t>
+              <a:t>Q1   </a:t>
             </a:r>
             <a:r>
               <a:rPr sz="2400" b="1" i="0">
@@ -9354,7 +9387,7 @@
                 <a:ea typeface="Malgun Gothic"/>
                 <a:cs typeface="Malgun Gothic"/>
               </a:rPr>
-              <a:t>뼈 기질의 두 성분과 각각이 담당하는 기계적 성질을 쓰고, 이를 확인하는 간단한 실험을 서술하시오.</a:t>
+              <a:t>뼈가 동시에 수행해야 하는 요구 가운데 서로 모순되는 것을 들고, 그 해결 방식을 설명하시오.</a:t>
             </a:r>
           </a:p>
         </p:txBody>
@@ -9422,7 +9455,7 @@
                 <a:ea typeface="Malgun Gothic"/>
                 <a:cs typeface="Malgun Gothic"/>
               </a:rPr>
-              <a:t>유기 성분인 I형 collagen이 인장 강도와 유연성을, 무기 성분인 hydroxyapatite가 압축 강도와 단단함을 담당한다. 뼈를 산에 담가 무기질을 녹이면 모양은 유지되지만 고무처럼 휘고, 태워서 유기 성분을 없애면 형태는 남지만 쉽게 바스러진다. 두 성분이 각각 없을 때 잃는 성질이 다르다는 것이 역할 분담의 근거다.</a:t>
+              <a:t>지지와 보호를 위해서는 단단하고 변하지 않아야 하지만, 무기질 저장소로서는 칼슘을 쉽게 꺼내 쓸 수 있어야 한다. 또 움직임의 비용을 줄이려면 가벼워야 한다. 뼈는 이를 끊임없이 허물고 다시 짓는 재형성으로 해결한다. 모양은 유지하면서 재료를 교체하므로 구조적 요구와 대사적 요구를 동시에 만족하며, 성인에서도 해마다 전체 골격의 약 10%가 교체된다. 가벼움은 재료를 중심축에서 먼 바깥에 배치한 관 구조와 힘의 방향을 따라 배열된 해면뼈 기둥으로 해결한다.</a:t>
             </a:r>
           </a:p>
         </p:txBody>
@@ -9608,7 +9641,7 @@
                 <a:ea typeface="Malgun Gothic"/>
                 <a:cs typeface="Malgun Gothic"/>
               </a:rPr>
-              <a:t>Q3   </a:t>
+              <a:t>Q2   </a:t>
             </a:r>
             <a:r>
               <a:rPr sz="2400" b="1" i="0">
@@ -9702,7 +9735,7 @@
                 <a:ea typeface="Malgun Gothic"/>
                 <a:cs typeface="Malgun Gothic"/>
               </a:rPr>
-              <a:t>골다공증과 골연화증의 차이를 기질과 무기질화의 관점에서 설명하고, 검사 소견의 차이를 쓰시오.</a:t>
+              <a:t>뼈 기질의 두 성분과 각각이 담당하는 기계적 성질을 쓰고, 이를 확인하는 간단한 실험을 서술하시오.</a:t>
             </a:r>
           </a:p>
         </p:txBody>
@@ -9770,7 +9803,7 @@
                 <a:ea typeface="Malgun Gothic"/>
                 <a:cs typeface="Malgun Gothic"/>
               </a:rPr>
-              <a:t>골다공증은 정상적으로 무기질화된 뼈의 양 자체가 줄어든 것이고, 골연화증은 기질은 정상적으로 만들어지는데 칼슘과 인이 충분히 침착되지 않아 뼈가 물러진 것이다. 골다공증은 대사가 정상이므로 칼슘, 인, alkaline phosphatase, PTH가 모두 정상이며 골절이 생기기 전까지 증상이 없다. 골연화증은 칼슘과 인이 낮고 alkaline phosphatase가 높으며 PTH가 이차적으로 올라가고, 뼈 통증과 미세 골절이 나타난다. 성장판이 열려 있는 소아에서는 같은 병태가 구루병으로 나타나 다리가 휜다.</a:t>
+              <a:t>유기 성분인 I형 collagen이 인장 강도와 유연성을, 무기 성분인 hydroxyapatite가 압축 강도와 단단함을 담당한다. 뼈를 산에 담가 무기질을 녹이면 모양은 유지되지만 고무처럼 휘고, 태워서 유기 성분을 없애면 형태는 남지만 쉽게 바스러진다. 두 성분이 각각 없을 때 잃는 성질이 다르다는 것이 역할 분담의 근거다.</a:t>
             </a:r>
           </a:p>
         </p:txBody>
@@ -9956,7 +9989,7 @@
                 <a:ea typeface="Malgun Gothic"/>
                 <a:cs typeface="Malgun Gothic"/>
               </a:rPr>
-              <a:t>Q4   </a:t>
+              <a:t>Q3   </a:t>
             </a:r>
             <a:r>
               <a:rPr sz="2400" b="1" i="0">
@@ -10050,7 +10083,7 @@
                 <a:ea typeface="Malgun Gothic"/>
                 <a:cs typeface="Malgun Gothic"/>
               </a:rPr>
-              <a:t>Osteoclast가 다른 세 세포와 기원이 다르다는 사실이 임상에서 어떤 결과를 낳는지 세 가지로 설명하시오.</a:t>
+              <a:t>골다공증과 골연화증의 차이를 기질과 무기질화의 관점에서 설명하고, 검사 소견의 차이를 쓰시오.</a:t>
             </a:r>
           </a:p>
         </p:txBody>
@@ -10118,7 +10151,7 @@
                 <a:ea typeface="Malgun Gothic"/>
                 <a:cs typeface="Malgun Gothic"/>
               </a:rPr>
-              <a:t>Osteoclast는 중간엽이 아니라 단핵구·대식세포 계통의 조혈 전구세포가 융합해 만들어진다. 첫째, 조혈 계통이므로 골수 이식으로 교체할 수 있고 osteoclast 기능 이상에 의한 골화석증이 골수 이식으로 치료된다. 둘째, 산 분비에 carbonic anhydrase II를 쓰므로 이 효소의 결핍은 골화석증과 신세뇨관 산증을 함께 일으킨다. 셋째, 골화석증에서는 뼈가 두꺼워지는데도 낡은 뼈가 교체되지 않아 미세 손상이 쌓여 골절이 잦고, 골수 공간이 좁아져 빈혈과 감염이, 신경 구멍이 좁아져 뇌신경 마비가 생긴다.</a:t>
+              <a:t>골다공증은 정상적으로 무기질화된 뼈의 양 자체가 줄어든 것이고, 골연화증은 기질은 정상적으로 만들어지는데 칼슘과 인이 충분히 침착되지 않아 뼈가 물러진 것이다. 골다공증은 대사가 정상이므로 칼슘, 인, alkaline phosphatase, PTH가 모두 정상이며 골절이 생기기 전까지 증상이 없다. 골연화증은 칼슘과 인이 낮고 alkaline phosphatase가 높으며 PTH가 이차적으로 올라가고, 뼈 통증과 미세 골절이 나타난다. 성장판이 열려 있는 소아에서는 같은 병태가 구루병으로 나타나 다리가 휜다.</a:t>
             </a:r>
           </a:p>
         </p:txBody>
@@ -10890,7 +10923,7 @@
                 <a:ea typeface="Malgun Gothic"/>
                 <a:cs typeface="Malgun Gothic"/>
               </a:rPr>
-              <a:t>Q5   </a:t>
+              <a:t>Q4   </a:t>
             </a:r>
             <a:r>
               <a:rPr sz="2400" b="1" i="0">
@@ -10984,7 +11017,7 @@
                 <a:ea typeface="Malgun Gothic"/>
                 <a:cs typeface="Malgun Gothic"/>
               </a:rPr>
-              <a:t>긴뼈의 몸통이 속이 빈 관 구조인 이유를 역학적으로 설명하시오.</a:t>
+              <a:t>Osteoclast가 다른 세 세포와 기원이 다르다는 사실이 임상에서 어떤 결과를 낳는지 세 가지로 설명하시오.</a:t>
             </a:r>
           </a:p>
         </p:txBody>
@@ -11052,7 +11085,7 @@
                 <a:ea typeface="Malgun Gothic"/>
                 <a:cs typeface="Malgun Gothic"/>
               </a:rPr>
-              <a:t>굽힘에 대한 저항은 재료가 중심축에서 멀리 있을수록 커진다. 따라서 같은 양의 재료라면 가운데를 비우고 바깥쪽에 배치하는 편이 훨씬 강하다. 속이 빈 구조는 재료를 아끼려다 생긴 타협이 아니라 주어진 재료로 강도를 최대화한 결과다. 또한 비워진 가운데 공간이 골수로 쓰여 조혈이 일어나므로 공간이 낭비되지도 않는다.</a:t>
+              <a:t>Osteoclast는 중간엽이 아니라 단핵구·대식세포 계통의 조혈 전구세포가 융합해 만들어진다. 첫째, 조혈 계통이므로 골수 이식으로 교체할 수 있고 osteoclast 기능 이상에 의한 골화석증이 골수 이식으로 치료된다. 둘째, 산 분비에 carbonic anhydrase II를 쓰므로 이 효소의 결핍은 골화석증과 신세뇨관 산증을 함께 일으킨다. 셋째, 골화석증에서는 뼈가 두꺼워지는데도 낡은 뼈가 교체되지 않아 미세 손상이 쌓여 골절이 잦고, 골수 공간이 좁아져 빈혈과 감염이, 신경 구멍이 좁아져 뇌신경 마비가 생긴다.</a:t>
             </a:r>
           </a:p>
         </p:txBody>
@@ -11238,7 +11271,7 @@
                 <a:ea typeface="Malgun Gothic"/>
                 <a:cs typeface="Malgun Gothic"/>
               </a:rPr>
-              <a:t>Q6   </a:t>
+              <a:t>Q5   </a:t>
             </a:r>
             <a:r>
               <a:rPr sz="2400" b="1" i="0">
@@ -11332,7 +11365,7 @@
                 <a:ea typeface="Malgun Gothic"/>
                 <a:cs typeface="Malgun Gothic"/>
               </a:rPr>
-              <a:t>막내골화와 연골내골화를 비교하고, 말단비대증에서 길이가 아니라 굵기와 얼굴뼈가 커지는 이유를 설명하시오.</a:t>
+              <a:t>긴뼈의 몸통이 속이 빈 관 구조인 이유를 역학적으로 설명하시오.</a:t>
             </a:r>
           </a:p>
         </p:txBody>
@@ -11400,7 +11433,7 @@
                 <a:ea typeface="Malgun Gothic"/>
                 <a:cs typeface="Malgun Gothic"/>
               </a:rPr>
-              <a:t>막내골화는 중간엽 세포가 직접 osteoblast로 분화해 뼈를 만드는 방식으로 머리뼈의 납작뼈, 얼굴뼈, 빗장뼈가 이렇게 생긴다. 연골내골화는 유리연골 모형을 먼저 만들고 뼈로 치환하는 방식으로 긴뼈를 포함한 대부분의 뼈가 이렇게 생기며 성장판을 남긴다. 말단비대증은 성장판이 닫힌 뒤에 GH가 과잉된 상태이므로 연골내골화에 의한 길이 성장은 불가능하다. 반면 막내골화로 자라는 얼굴뼈와 턱, 이마, 그리고 뼈의 둘레 방향 성장은 계속되므로 굵어지고 커진다.</a:t>
+              <a:t>굽힘에 대한 저항은 재료가 중심축에서 멀리 있을수록 커진다. 따라서 같은 양의 재료라면 가운데를 비우고 바깥쪽에 배치하는 편이 훨씬 강하다. 속이 빈 구조는 재료를 아끼려다 생긴 타협이 아니라 주어진 재료로 강도를 최대화한 결과다. 또한 비워진 가운데 공간이 골수로 쓰여 조혈이 일어나므로 공간이 낭비되지도 않는다.</a:t>
             </a:r>
           </a:p>
         </p:txBody>
@@ -11586,7 +11619,7 @@
                 <a:ea typeface="Malgun Gothic"/>
                 <a:cs typeface="Malgun Gothic"/>
               </a:rPr>
-              <a:t>Q7   </a:t>
+              <a:t>Q6   </a:t>
             </a:r>
             <a:r>
               <a:rPr sz="2400" b="1" i="0">
@@ -11680,7 +11713,7 @@
                 <a:ea typeface="Malgun Gothic"/>
                 <a:cs typeface="Malgun Gothic"/>
               </a:rPr>
-              <a:t>성장판의 구역을 순서대로 쓰고, 성장판이 닫히는 기전을 설명하시오.</a:t>
+              <a:t>막내골화와 연골내골화를 비교하고, 말단비대증에서 길이가 아니라 굵기와 얼굴뼈가 커지는 이유를 설명하시오.</a:t>
             </a:r>
           </a:p>
         </p:txBody>
@@ -11748,7 +11781,7 @@
                 <a:ea typeface="Malgun Gothic"/>
                 <a:cs typeface="Malgun Gothic"/>
               </a:rPr>
-              <a:t>골단에서 골간 쪽으로 휴지 구역, 증식 구역, 비대 구역, 석회화 구역, 골화 구역의 순서다. 증식 구역에서 연골세포가 분열해 세로로 쌓이고 비대 구역에서 세포가 크게 부풀어 길이가 늘며, 석회화와 골화를 거쳐 뼈로 치환된다. 사춘기에 estrogen이 올라가면 증식 구역의 세포가 고갈되고 성장판 전체가 뼈로 치환되어 닫힌다. 남성에서도 testosterone이 aromatase를 통해 estrogen으로 전환되어 작용하므로, aromatase 결핍이나 estrogen 수용체 결함에서는 성인이 되어도 키가 계속 자란다.</a:t>
+              <a:t>막내골화는 중간엽 세포가 직접 osteoblast로 분화해 뼈를 만드는 방식으로 머리뼈의 납작뼈, 얼굴뼈, 빗장뼈가 이렇게 생긴다. 연골내골화는 유리연골 모형을 먼저 만들고 뼈로 치환하는 방식으로 긴뼈를 포함한 대부분의 뼈가 이렇게 생기며 성장판을 남긴다. 말단비대증은 성장판이 닫힌 뒤에 GH가 과잉된 상태이므로 연골내골화에 의한 길이 성장은 불가능하다. 반면 막내골화로 자라는 얼굴뼈와 턱, 이마, 그리고 뼈의 둘레 방향 성장은 계속되므로 굵어지고 커진다.</a:t>
             </a:r>
           </a:p>
         </p:txBody>
@@ -11934,7 +11967,7 @@
                 <a:ea typeface="Malgun Gothic"/>
                 <a:cs typeface="Malgun Gothic"/>
               </a:rPr>
-              <a:t>Q8   </a:t>
+              <a:t>Q7   </a:t>
             </a:r>
             <a:r>
               <a:rPr sz="2400" b="1" i="0">
@@ -12028,7 +12061,7 @@
                 <a:ea typeface="Malgun Gothic"/>
                 <a:cs typeface="Malgun Gothic"/>
               </a:rPr>
-              <a:t>재형성에서 흡수와 형성의 속도가 비대칭이라는 사실이 임상적으로 뜻하는 바를 설명하시오.</a:t>
+              <a:t>성장판의 구역을 순서대로 쓰고, 성장판이 닫히는 기전을 설명하시오.</a:t>
             </a:r>
           </a:p>
         </p:txBody>
@@ -12096,7 +12129,7 @@
                 <a:ea typeface="Malgun Gothic"/>
                 <a:cs typeface="Malgun Gothic"/>
               </a:rPr>
-              <a:t>Osteoclast에 의한 흡수는 약 2~3주에 끝나지만 osteoblast에 의한 형성은 약 3개월이 걸린다. 따라서 재형성의 빈도 자체가 올라가면 어느 시점에나 파였지만 아직 채워지지 않은 자리가 많아져 전체 골량이 순감소한다. 폐경 후 골소실이 빠른 것이 estrogen 감소로 재형성 빈도가 올라가기 때문이며, 흡수를 억제하는 약물이 효과를 내는 것도 이 빈도를 낮추어 미완성 상태의 자리를 줄이기 때문이다.</a:t>
+              <a:t>골단에서 골간 쪽으로 휴지 구역, 증식 구역, 비대 구역, 석회화 구역, 골화 구역의 순서다. 증식 구역에서 연골세포가 분열해 세로로 쌓이고 비대 구역에서 세포가 크게 부풀어 길이가 늘며, 석회화와 골화를 거쳐 뼈로 치환된다. 사춘기에 estrogen이 올라가면 증식 구역의 세포가 고갈되고 성장판 전체가 뼈로 치환되어 닫힌다. 남성에서도 testosterone이 aromatase를 통해 estrogen으로 전환되어 작용하므로, aromatase 결핍이나 estrogen 수용체 결함에서는 성인이 되어도 키가 계속 자란다.</a:t>
             </a:r>
           </a:p>
         </p:txBody>
@@ -12282,7 +12315,7 @@
                 <a:ea typeface="Malgun Gothic"/>
                 <a:cs typeface="Malgun Gothic"/>
               </a:rPr>
-              <a:t>Q9   </a:t>
+              <a:t>Q8   </a:t>
             </a:r>
             <a:r>
               <a:rPr sz="2400" b="1" i="0">
@@ -12376,7 +12409,7 @@
                 <a:ea typeface="Malgun Gothic"/>
                 <a:cs typeface="Malgun Gothic"/>
               </a:rPr>
-              <a:t>RANKL과 OPG가 뼈 흡수를 조절하는 방식을 설명하고, PTH가 osteoclast에 작용하는 경로를 쓰시오.</a:t>
+              <a:t>재형성에서 흡수와 형성의 속도가 비대칭이라는 사실이 임상적으로 뜻하는 바를 설명하시오.</a:t>
             </a:r>
           </a:p>
         </p:txBody>
@@ -12444,7 +12477,7 @@
                 <a:ea typeface="Malgun Gothic"/>
                 <a:cs typeface="Malgun Gothic"/>
               </a:rPr>
-              <a:t>RANKL은 osteoblast 계열 세포와 osteocyte가 분비해 osteoclast 전구세포의 RANK에 결합함으로써 분화와 활성을 일으킨다. OPG는 같은 세포들이 분비하는 미끼 수용체로 RANKL을 가로채 RANK에 닿지 못하게 한다. 따라서 흡수량은 두 분자의 비율이 정하며, 뼈를 짓는 쪽이 허무는 쪽을 지휘하는 구조다. Osteoclast에는 PTH 수용체가 없으므로 PTH는 직접 작용하지 않는다. PTH는 osteoblast 계열 세포와 osteocyte에 작용해 RANKL을 늘리고 OPG를 줄여 간접적으로 osteoclast를 활성화한다.</a:t>
+              <a:t>Osteoclast에 의한 흡수는 약 2~3주에 끝나지만 osteoblast에 의한 형성은 약 3개월이 걸린다. 따라서 재형성의 빈도 자체가 올라가면 어느 시점에나 파였지만 아직 채워지지 않은 자리가 많아져 전체 골량이 순감소한다. 폐경 후 골소실이 빠른 것이 estrogen 감소로 재형성 빈도가 올라가기 때문이며, 흡수를 억제하는 약물이 효과를 내는 것도 이 빈도를 낮추어 미완성 상태의 자리를 줄이기 때문이다.</a:t>
             </a:r>
           </a:p>
         </p:txBody>
@@ -12630,7 +12663,7 @@
                 <a:ea typeface="Malgun Gothic"/>
                 <a:cs typeface="Malgun Gothic"/>
               </a:rPr>
-              <a:t>Q10   </a:t>
+              <a:t>Q9   </a:t>
             </a:r>
             <a:r>
               <a:rPr sz="2400" b="1" i="0">
@@ -12724,7 +12757,7 @@
                 <a:ea typeface="Malgun Gothic"/>
                 <a:cs typeface="Malgun Gothic"/>
               </a:rPr>
-              <a:t>간헐적 PTH 투여가 지속적 PTH 상승과 반대 결과를 내는 현상을 설명하고, 이것이 어떤 일반 원리를 보여 주는지 쓰시오.</a:t>
+              <a:t>RANKL과 OPG가 뼈 흡수를 조절하는 방식을 설명하고, PTH가 osteoclast에 작용하는 경로를 쓰시오.</a:t>
             </a:r>
           </a:p>
         </p:txBody>
@@ -12792,7 +12825,7 @@
                 <a:ea typeface="Malgun Gothic"/>
                 <a:cs typeface="Malgun Gothic"/>
               </a:rPr>
-              <a:t>PTH가 지속적으로 높으면 RANKL이 늘고 OPG가 줄어 골흡수가 우세해져 뼈가 줄어든다. 그러나 하루 한 번처럼 간헐적으로 투여하면 osteoblast의 활동과 생존이 더 크게 자극되어 뼈 형성이 흡수를 앞서고 골량이 늘어난다. Teriparatide가 이 방식을 쓴다. 이는 같은 신호 분자라도 농도의 시간적 양상이 다르면 반대 결과가 나올 수 있다는 원리를 보여 주며, GnRH의 박동성 분비가 지속 투여 시 오히려 생식축을 억제하는 것과 같은 구조다.</a:t>
+              <a:t>RANKL은 osteoblast 계열 세포와 osteocyte가 분비해 osteoclast 전구세포의 RANK에 결합함으로써 분화와 활성을 일으킨다. OPG는 같은 세포들이 분비하는 미끼 수용체로 RANKL을 가로채 RANK에 닿지 못하게 한다. 따라서 흡수량은 두 분자의 비율이 정하며, 뼈를 짓는 쪽이 허무는 쪽을 지휘하는 구조다. Osteoclast에는 PTH 수용체가 없으므로 PTH는 직접 작용하지 않는다. PTH는 osteoblast 계열 세포와 osteocyte에 작용해 RANKL을 늘리고 OPG를 줄여 간접적으로 osteoclast를 활성화한다.</a:t>
             </a:r>
           </a:p>
         </p:txBody>
@@ -12978,7 +13011,7 @@
                 <a:ea typeface="Malgun Gothic"/>
                 <a:cs typeface="Malgun Gothic"/>
               </a:rPr>
-              <a:t>Q11   </a:t>
+              <a:t>Q10   </a:t>
             </a:r>
             <a:r>
               <a:rPr sz="2400" b="1" i="0">
@@ -13072,7 +13105,7 @@
                 <a:ea typeface="Malgun Gothic"/>
                 <a:cs typeface="Malgun Gothic"/>
               </a:rPr>
-              <a:t>네 가지 대사성 뼈 질환을 칼슘, 인, alkaline phosphatase, PTH의 조합으로 구분하시오.</a:t>
+              <a:t>간헐적 PTH 투여가 지속적 PTH 상승과 반대 결과를 내는 현상을 설명하고, 이것이 어떤 일반 원리를 보여 주는지 쓰시오.</a:t>
             </a:r>
           </a:p>
         </p:txBody>
@@ -13140,7 +13173,7 @@
                 <a:ea typeface="Malgun Gothic"/>
                 <a:cs typeface="Malgun Gothic"/>
               </a:rPr>
-              <a:t>골다공증은 네 값이 모두 정상이다. 뼈의 양이 줄었을 뿐 대사가 정상이기 때문이며, 골절 전까지 증상이 없다. 골연화증과 구루병은 칼슘과 인이 낮고 alkaline phosphatase가 높으며 PTH가 이차적으로 올라간다. 일차성 부갑상샘 기능항진증은 칼슘이 높고 인이 낮으며 PTH가 높다. Paget 병은 국소적으로 재형성이 폭주하는 상태로 칼슘과 인은 대개 정상인데 alkaline phosphatase만 크게 올라간다.</a:t>
+              <a:t>PTH가 지속적으로 높으면 RANKL이 늘고 OPG가 줄어 골흡수가 우세해져 뼈가 줄어든다. 그러나 하루 한 번처럼 간헐적으로 투여하면 osteoblast의 활동과 생존이 더 크게 자극되어 뼈 형성이 흡수를 앞서고 골량이 늘어난다. Teriparatide가 이 방식을 쓴다. 이는 같은 신호 분자라도 농도의 시간적 양상이 다르면 반대 결과가 나올 수 있다는 원리를 보여 주며, GnRH의 박동성 분비가 지속 투여 시 오히려 생식축을 억제하는 것과 같은 구조다.</a:t>
             </a:r>
           </a:p>
         </p:txBody>
@@ -13326,7 +13359,7 @@
                 <a:ea typeface="Malgun Gothic"/>
                 <a:cs typeface="Malgun Gothic"/>
               </a:rPr>
-              <a:t>Q12   </a:t>
+              <a:t>Q11   </a:t>
             </a:r>
             <a:r>
               <a:rPr sz="2400" b="1" i="0">
@@ -13420,7 +13453,7 @@
                 <a:ea typeface="Malgun Gothic"/>
                 <a:cs typeface="Malgun Gothic"/>
               </a:rPr>
-              <a:t>Osteocyte가 기계적 자극을 감지하는 방식과 그에 대한 반응을 설명하시오.</a:t>
+              <a:t>네 가지 대사성 뼈 질환을 칼슘, 인, alkaline phosphatase, PTH의 조합으로 구분하시오.</a:t>
             </a:r>
           </a:p>
         </p:txBody>
@@ -13488,7 +13521,7 @@
                 <a:ea typeface="Malgun Gothic"/>
                 <a:cs typeface="Malgun Gothic"/>
               </a:rPr>
-              <a:t>뼈에 하중이 걸리면 뼈가 미세하게 변형되고 lacuna와 canaliculi 안의 액체가 흐른다. Osteocyte의 돌기가 이 액체 흐름에 의한 전단력을 감지한다. 뼈 자체의 변형량은 매우 작지만 좁은 통로에서의 액체 이동은 충분히 큰 신호가 된다. 하중을 충분히 받으면 osteocyte가 sclerostin 분비를 줄이고, sclerostin이 억제하던 Wnt 신호가 살아나 osteoblast의 활동이 늘어 뼈가 더해진다. 하중이 없으면 sclerostin과 RANKL이 늘어 뼈가 줄어든다.</a:t>
+              <a:t>골다공증은 네 값이 모두 정상이다. 뼈의 양이 줄었을 뿐 대사가 정상이기 때문이며, 골절 전까지 증상이 없다. 골연화증과 구루병은 칼슘과 인이 낮고 alkaline phosphatase가 높으며 PTH가 이차적으로 올라간다. 일차성 부갑상샘 기능항진증은 칼슘이 높고 인이 낮으며 PTH가 높다. Paget 병은 국소적으로 재형성이 폭주하는 상태로 칼슘과 인은 대개 정상인데 alkaline phosphatase만 크게 올라간다.</a:t>
             </a:r>
           </a:p>
         </p:txBody>
@@ -13674,7 +13707,7 @@
                 <a:ea typeface="Malgun Gothic"/>
                 <a:cs typeface="Malgun Gothic"/>
               </a:rPr>
-              <a:t>Q13   </a:t>
+              <a:t>Q12   </a:t>
             </a:r>
             <a:r>
               <a:rPr sz="2400" b="1" i="0">
@@ -13768,7 +13801,7 @@
                 <a:ea typeface="Malgun Gothic"/>
                 <a:cs typeface="Malgun Gothic"/>
               </a:rPr>
-              <a:t>관절연골에 혈관이 없다는 사실에서 따라 나오는 결과를 세 가지 쓰시오.</a:t>
+              <a:t>Osteocyte가 기계적 자극을 감지하는 방식과 그에 대한 반응을 설명하시오.</a:t>
             </a:r>
           </a:p>
         </p:txBody>
@@ -13836,7 +13869,7 @@
                 <a:ea typeface="Malgun Gothic"/>
                 <a:cs typeface="Malgun Gothic"/>
               </a:rPr>
-              <a:t>첫째, 영양을 윤활액에서 확산으로 받아야 하며 관절이 움직일 때 연골이 눌렸다 펴지면서 액체가 드나드는 것이 교환을 돕는다. 그래서 움직이지 않는 관절의 연골이 나빠진다. 둘째, 신경도 없으므로 연골 자체는 통증을 느끼지 않으며 관절 통증은 윤활막, 뼈, 인대, 관절주머니에서 온다. 셋째, 재생이 거의 일어나지 않아 손상된 연골이 원래 조직으로 복구되지 않고 기계적 성질이 떨어지는 섬유연골로 메워진다.</a:t>
+              <a:t>뼈에 하중이 걸리면 뼈가 미세하게 변형되고 lacuna와 canaliculi 안의 액체가 흐른다. Osteocyte의 돌기가 이 액체 흐름에 의한 전단력을 감지한다. 뼈 자체의 변형량은 매우 작지만 좁은 통로에서의 액체 이동은 충분히 큰 신호가 된다. 하중을 충분히 받으면 osteocyte가 sclerostin 분비를 줄이고, sclerostin이 억제하던 Wnt 신호가 살아나 osteoblast의 활동이 늘어 뼈가 더해진다. 하중이 없으면 sclerostin과 RANKL이 늘어 뼈가 줄어든다.</a:t>
             </a:r>
           </a:p>
         </p:txBody>
@@ -14022,7 +14055,7 @@
                 <a:ea typeface="Malgun Gothic"/>
                 <a:cs typeface="Malgun Gothic"/>
               </a:rPr>
-              <a:t>Q14   </a:t>
+              <a:t>Q13   </a:t>
             </a:r>
             <a:r>
               <a:rPr sz="2400" b="1" i="0">
@@ -14116,7 +14149,7 @@
                 <a:ea typeface="Malgun Gothic"/>
                 <a:cs typeface="Malgun Gothic"/>
               </a:rPr>
-              <a:t>골관절염과 류마티스 관절염을 침범 부위와 증상 양상으로 구분하시오.</a:t>
+              <a:t>관절연골에 혈관이 없다는 사실에서 따라 나오는 결과를 세 가지 쓰시오.</a:t>
             </a:r>
           </a:p>
         </p:txBody>
@@ -14184,7 +14217,7 @@
                 <a:ea typeface="Malgun Gothic"/>
                 <a:cs typeface="Malgun Gothic"/>
               </a:rPr>
-              <a:t>골관절염은 연골 마모가 중심인 비염증성 과정으로 체중을 받는 관절과 손의 원위지간관절을 비대칭적으로 침범하고, 아침 경직이 30분 이내로 짧으며 쓸수록 아프고 쉬면 나아진다. 방사선에서 관절 간격이 비대칭적으로 좁아지고 뼈곁돌기와 연골밑 경화가 보인다. 류마티스 관절염은 윤활막의 자가면역 염증으로 손의 중수지절관절과 근위지간관절을 대칭적으로 침범하고 원위지간관절은 대개 보존되며, 아침 경직이 1시간 이상 지속되고 움직이면 나아진다. 방사선에서 관절 주위 골감소와 미란이 보인다.</a:t>
+              <a:t>첫째, 영양을 윤활액에서 확산으로 받아야 하며 관절이 움직일 때 연골이 눌렸다 펴지면서 액체가 드나드는 것이 교환을 돕는다. 그래서 움직이지 않는 관절의 연골이 나빠진다. 둘째, 신경도 없으므로 연골 자체는 통증을 느끼지 않으며 관절 통증은 윤활막, 뼈, 인대, 관절주머니에서 온다. 셋째, 재생이 거의 일어나지 않아 손상된 연골이 원래 조직으로 복구되지 않고 기계적 성질이 떨어지는 섬유연골로 메워진다.</a:t>
             </a:r>
           </a:p>
         </p:txBody>
@@ -14724,7 +14757,7 @@
                 <a:ea typeface="Malgun Gothic"/>
                 <a:cs typeface="Malgun Gothic"/>
               </a:rPr>
-              <a:t>Q15   </a:t>
+              <a:t>Q14   </a:t>
             </a:r>
             <a:r>
               <a:rPr sz="2400" b="1" i="0">
@@ -14818,7 +14851,7 @@
                 <a:ea typeface="Malgun Gothic"/>
                 <a:cs typeface="Malgun Gothic"/>
               </a:rPr>
-              <a:t>골절 치유의 단계를 쓰고, 치유가 지연되는 조건을 기전과 함께 설명하시오.</a:t>
+              <a:t>골관절염과 류마티스 관절염을 침범 부위와 증상 양상으로 구분하시오.</a:t>
             </a:r>
           </a:p>
         </p:txBody>
@@ -14886,7 +14919,7 @@
                 <a:ea typeface="Malgun Gothic"/>
                 <a:cs typeface="Malgun Gothic"/>
               </a:rPr>
-              <a:t>혈종 형성, 염증 세포와 혈관의 침입, 연골성 가골 형성, 연골내골화와 같은 과정을 통한 뼈로의 치환, 그리고 재형성에 의한 모양 정리의 순서로 진행한다. 치유가 지연되는 조건은 각 단계의 요구와 대응한다. 혈액 공급이 나쁘면 세포와 산소가 공급되지 않아 늦어지고, 골절부가 안정되지 않으면 형성된 조직이 반복해 손상되며, 감염이 있으면 염증이 치유로 넘어가지 못한다. 흡연은 혈류를 줄이고 당뇨는 혈관과 세포 기능을 떨어뜨리며 영양 부족은 재료를 제한한다. 넙다리뼈 목이나 손배뼈처럼 혈액 공급이 한 방향에서만 들어오는 부위는 골절이 혈관을 끊어 무혈성 괴사가 생길 수 있다.</a:t>
+              <a:t>골관절염은 연골 마모가 중심인 비염증성 과정으로 체중을 받는 관절과 손의 원위지간관절을 비대칭적으로 침범하고, 아침 경직이 30분 이내로 짧으며 쓸수록 아프고 쉬면 나아진다. 방사선에서 관절 간격이 비대칭적으로 좁아지고 뼈곁돌기와 연골밑 경화가 보인다. 류마티스 관절염은 윤활막의 자가면역 염증으로 손의 중수지절관절과 근위지간관절을 대칭적으로 침범하고 원위지간관절은 대개 보존되며, 아침 경직이 1시간 이상 지속되고 움직이면 나아진다. 방사선에서 관절 주위 골감소와 미란이 보인다.</a:t>
             </a:r>
           </a:p>
         </p:txBody>
@@ -15072,7 +15105,7 @@
                 <a:ea typeface="Malgun Gothic"/>
                 <a:cs typeface="Malgun Gothic"/>
               </a:rPr>
-              <a:t>Q16   </a:t>
+              <a:t>Q15   </a:t>
             </a:r>
             <a:r>
               <a:rPr sz="2400" b="1" i="0">
@@ -15166,7 +15199,7 @@
                 <a:ea typeface="Malgun Gothic"/>
                 <a:cs typeface="Malgun Gothic"/>
               </a:rPr>
-              <a:t>척추의 굽이가 하중을 견디는 데 유리한 이유를 쓰고, 이차 굽이가 생기는 시기를 설명하시오.</a:t>
+              <a:t>골절 치유의 단계를 쓰고, 치유가 지연되는 조건을 기전과 함께 설명하시오.</a:t>
             </a:r>
           </a:p>
         </p:txBody>
@@ -15234,7 +15267,7 @@
                 <a:ea typeface="Malgun Gothic"/>
                 <a:cs typeface="Malgun Gothic"/>
               </a:rPr>
-              <a:t>척추는 옆에서 보면 목과 허리가 앞으로, 등과 엉치가 뒤로 볼록한 네 개의 굽이를 이룬다. 이 굽이가 용수철처럼 작용해 충격을 흡수하고 하중을 분산하므로 곧은 기둥보다 훨씬 큰 힘을 견딘다. 태아기에는 전체가 뒤로 볼록한 하나의 굽이만 있고, 아기가 목을 들면서 목의 굽이가, 걷기 시작하면서 허리의 굽이가 생긴다. 이 두 이차 굽이는 발달 과정에서 기능적 요구에 따라 만들어진 것이다.</a:t>
+              <a:t>혈종 형성, 염증 세포와 혈관의 침입, 연골성 가골 형성, 연골내골화와 같은 과정을 통한 뼈로의 치환, 그리고 재형성에 의한 모양 정리의 순서로 진행한다. 치유가 지연되는 조건은 각 단계의 요구와 대응한다. 혈액 공급이 나쁘면 세포와 산소가 공급되지 않아 늦어지고, 골절부가 안정되지 않으면 형성된 조직이 반복해 손상되며, 감염이 있으면 염증이 치유로 넘어가지 못한다. 흡연은 혈류를 줄이고 당뇨는 혈관과 세포 기능을 떨어뜨리며 영양 부족은 재료를 제한한다. 넙다리뼈 목이나 손배뼈처럼 혈액 공급이 한 방향에서만 들어오는 부위는 골절이 혈관을 끊어 무혈성 괴사가 생길 수 있다.</a:t>
             </a:r>
           </a:p>
         </p:txBody>
@@ -15420,7 +15453,7 @@
                 <a:ea typeface="Malgun Gothic"/>
                 <a:cs typeface="Malgun Gothic"/>
               </a:rPr>
-              <a:t>Q17   </a:t>
+              <a:t>Q16   </a:t>
             </a:r>
             <a:r>
               <a:rPr sz="2400" b="1" i="0">
@@ -15514,7 +15547,7 @@
                 <a:ea typeface="Malgun Gothic"/>
                 <a:cs typeface="Malgun Gothic"/>
               </a:rPr>
-              <a:t>어깨관절과 엉덩관절의 구조적 차이를 각각의 기능적 요구와 연결해 설명하시오.</a:t>
+              <a:t>척추의 굽이가 하중을 견디는 데 유리한 이유를 쓰고, 이차 굽이가 생기는 시기를 설명하시오.</a:t>
             </a:r>
           </a:p>
         </p:txBody>
@@ -15582,7 +15615,7 @@
                 <a:ea typeface="Malgun Gothic"/>
                 <a:cs typeface="Malgun Gothic"/>
               </a:rPr>
-              <a:t>어깨는 운동 범위가 요구되므로 관절오목이 얕고 이음뼈가 빗장뼈 한 곳에서만 몸통과 관절하며 뼈가 가늘다. 그 결과 사람 몸에서 운동 범위가 가장 크지만 탈구도 가장 흔하다. 엉덩관절은 체중 지지와 안정성이 요구되므로 절구가 깊어 넙다리뼈 머리를 감싸고 볼기뼈가 엉치뼈와 단단히 결합하며 뼈가 굵다. 그 결과 탈구가 드물고 일어나려면 큰 외력이 필요하다. 움직임과 안정성을 맞바꾸는 원리가 같은 몸 안에서 두 방향으로 극단화된 예다.</a:t>
+              <a:t>척추는 옆에서 보면 목과 허리가 앞으로, 등과 엉치가 뒤로 볼록한 네 개의 굽이를 이룬다. 이 굽이가 용수철처럼 작용해 충격을 흡수하고 하중을 분산하므로 곧은 기둥보다 훨씬 큰 힘을 견딘다. 태아기에는 전체가 뒤로 볼록한 하나의 굽이만 있고, 아기가 목을 들면서 목의 굽이가, 걷기 시작하면서 허리의 굽이가 생긴다. 이 두 이차 굽이는 발달 과정에서 기능적 요구에 따라 만들어진 것이다.</a:t>
             </a:r>
           </a:p>
         </p:txBody>
@@ -15768,7 +15801,7 @@
                 <a:ea typeface="Malgun Gothic"/>
                 <a:cs typeface="Malgun Gothic"/>
               </a:rPr>
-              <a:t>Q18   </a:t>
+              <a:t>Q17   </a:t>
             </a:r>
             <a:r>
               <a:rPr sz="2400" b="1" i="0">
@@ -15862,7 +15895,7 @@
                 <a:ea typeface="Malgun Gothic"/>
                 <a:cs typeface="Malgun Gothic"/>
               </a:rPr>
-              <a:t>종자뼈의 역할을 무릎뼈를 예로 설명하시오.</a:t>
+              <a:t>어깨관절과 엉덩관절의 구조적 차이를 각각의 기능적 요구와 연결해 설명하시오.</a:t>
             </a:r>
           </a:p>
         </p:txBody>
@@ -15930,7 +15963,7 @@
                 <a:ea typeface="Malgun Gothic"/>
                 <a:cs typeface="Malgun Gothic"/>
               </a:rPr>
-              <a:t>종자뼈는 힘줄 안에 생긴 뼈다. 무릎뼈는 넙다리네갈래근의 힘줄 안에 있으며, 힘줄이 무릎관절 앞에서 꺾이는 각도를 키워 관절 중심으로부터의 모멘트 팔을 늘린다. 같은 근력으로 더 큰 토크를 낼 수 있게 하는 장치이며, 무릎뼈를 제거하면 넙다리네갈래근의 효율이 크게 떨어진다. 지렛대의 모멘트 팔을 늘리는 역학적 해법이 뼈의 형태로 구현된 예다.</a:t>
+              <a:t>어깨는 운동 범위가 요구되므로 관절오목이 얕고 이음뼈가 빗장뼈 한 곳에서만 몸통과 관절하며 뼈가 가늘다. 그 결과 사람 몸에서 운동 범위가 가장 크지만 탈구도 가장 흔하다. 엉덩관절은 체중 지지와 안정성이 요구되므로 절구가 깊어 넙다리뼈 머리를 감싸고 볼기뼈가 엉치뼈와 단단히 결합하며 뼈가 굵다. 그 결과 탈구가 드물고 일어나려면 큰 외력이 필요하다. 움직임과 안정성을 맞바꾸는 원리가 같은 몸 안에서 두 방향으로 극단화된 예다.</a:t>
             </a:r>
           </a:p>
         </p:txBody>
@@ -16116,7 +16149,7 @@
                 <a:ea typeface="Malgun Gothic"/>
                 <a:cs typeface="Malgun Gothic"/>
               </a:rPr>
-              <a:t>Q19   </a:t>
+              <a:t>Q18   </a:t>
             </a:r>
             <a:r>
               <a:rPr sz="2400" b="1" i="0">
@@ -16210,7 +16243,7 @@
                 <a:ea typeface="Malgun Gothic"/>
                 <a:cs typeface="Malgun Gothic"/>
               </a:rPr>
-              <a:t>긴뼈의 세 갈래 혈액 공급을 쓰고, 넙다리뼈 목 골절과 몸통 골절의 예후가 다른 이유를 설명하시오.</a:t>
+              <a:t>종자뼈의 역할을 무릎뼈를 예로 설명하시오.</a:t>
             </a:r>
           </a:p>
         </p:txBody>
@@ -16278,7 +16311,7 @@
                 <a:ea typeface="Malgun Gothic"/>
                 <a:cs typeface="Malgun Gothic"/>
               </a:rPr>
-              <a:t>영양 동맥이 몸통 가운데로 들어와 치밀뼈 안쪽 3분의 2와 골수를, 골막 동맥이 바깥 3분의 1을, 골단 동맥이 뼈 끝을 담당한다. 영양 동맥이 끊겨도 골막 동맥이 남으면 치유가 진행된다. 그런데 넙다리뼈 머리는 혈관이 관절면 쪽에서 거꾸로 올라오는 역행성 공급을 받으므로, 목 부위에서 골절이 생기면 그 혈관이 끊겨 머리 조각이 혈액을 받지 못하고 무혈성 괴사에 빠진다. 몸통 골절은 주위에 근육과 골막의 혈류가 풍부해 치유가 비교적 잘 된다.</a:t>
+              <a:t>종자뼈는 힘줄 안에 생긴 뼈다. 무릎뼈는 넙다리네갈래근의 힘줄 안에 있으며, 힘줄이 무릎관절 앞에서 꺾이는 각도를 키워 관절 중심으로부터의 모멘트 팔을 늘린다. 같은 근력으로 더 큰 토크를 낼 수 있게 하는 장치이며, 무릎뼈를 제거하면 넙다리네갈래근의 효율이 크게 떨어진다. 지렛대의 모멘트 팔을 늘리는 역학적 해법이 뼈의 형태로 구현된 예다.</a:t>
             </a:r>
           </a:p>
         </p:txBody>
@@ -16464,7 +16497,7 @@
                 <a:ea typeface="Malgun Gothic"/>
                 <a:cs typeface="Malgun Gothic"/>
               </a:rPr>
-              <a:t>Q20   </a:t>
+              <a:t>Q19   </a:t>
             </a:r>
             <a:r>
               <a:rPr sz="2400" b="1" i="0">
@@ -16558,7 +16591,7 @@
                 <a:ea typeface="Malgun Gothic"/>
                 <a:cs typeface="Malgun Gothic"/>
               </a:rPr>
-              <a:t>성인에서 적색 골수가 남는 부위를 쓰고, 이 사실이 임상에서 어떻게 쓰이는지 설명하시오.</a:t>
+              <a:t>긴뼈의 세 갈래 혈액 공급을 쓰고, 넙다리뼈 목 골절과 몸통 골절의 예후가 다른 이유를 설명하시오.</a:t>
             </a:r>
           </a:p>
         </p:txBody>
@@ -16626,7 +16659,7 @@
                 <a:ea typeface="Malgun Gothic"/>
                 <a:cs typeface="Malgun Gothic"/>
               </a:rPr>
-              <a:t>소아에서는 거의 모든 뼈에 적색 골수가 있지만 성인에서는 축성 골격과 긴뼈의 몸쪽 끝, 즉 척추, 복장뼈, 갈비뼈, 골반, 넙다리뼈와 위팔뼈의 몸쪽에 남고 나머지는 지방으로 대치된 황색 골수가 된다. 따라서 골수 검사는 적색 골수가 있는 엉덩뼈 능선에서 시행한다. 또 뼈 전이가 적색 골수가 있는 척추, 골반, 갈비뼈에 먼저 나타나는 경향이 있는데, 혈류가 풍부하고 혈관 구조가 느린 흐름을 허용하기 때문으로 설명된다.</a:t>
+              <a:t>영양 동맥이 몸통 가운데로 들어와 치밀뼈 안쪽 3분의 2와 골수를, 골막 동맥이 바깥 3분의 1을, 골단 동맥이 뼈 끝을 담당한다. 영양 동맥이 끊겨도 골막 동맥이 남으면 치유가 진행된다. 그런데 넙다리뼈 머리는 혈관이 관절면 쪽에서 거꾸로 올라오는 역행성 공급을 받으므로, 목 부위에서 골절이 생기면 그 혈관이 끊겨 머리 조각이 혈액을 받지 못하고 무혈성 괴사에 빠진다. 몸통 골절은 주위에 근육과 골막의 혈류가 풍부해 치유가 비교적 잘 된다.</a:t>
             </a:r>
           </a:p>
         </p:txBody>
@@ -16812,7 +16845,7 @@
                 <a:ea typeface="Malgun Gothic"/>
                 <a:cs typeface="Malgun Gothic"/>
               </a:rPr>
-              <a:t>Q21   </a:t>
+              <a:t>Q20   </a:t>
             </a:r>
             <a:r>
               <a:rPr sz="2400" b="1" i="0">
@@ -16906,7 +16939,7 @@
                 <a:ea typeface="Malgun Gothic"/>
                 <a:cs typeface="Malgun Gothic"/>
               </a:rPr>
-              <a:t>골용해성 전이와 골형성성 전이의 기전을 재형성 조절의 관점에서 설명하고 대표적인 원발암을 드시오.</a:t>
+              <a:t>성인에서 적색 골수가 남는 부위를 쓰고, 이 사실이 임상에서 어떻게 쓰이는지 설명하시오.</a:t>
             </a:r>
           </a:p>
         </p:txBody>
@@ -16974,7 +17007,7 @@
                 <a:ea typeface="Malgun Gothic"/>
                 <a:cs typeface="Malgun Gothic"/>
               </a:rPr>
-              <a:t>골용해성 전이는 종양세포가 RANKL 생산을 늘리거나 RANKL을 유도하는 인자를 분비해 osteoclast를 과도하게 활성화한 결과이며, 뼈가 녹아 방사선에서 구멍처럼 보인다. 유방암, 폐암, 다발골수종에서 흔하다. 골형성성 전이는 종양세포가 osteoblast를 자극해 무질서한 뼈가 과도하게 만들어진 것으로 방사선에서 하얗게 보이며 전립선암에서 특징적이다. 두 경우 모두 종양이 뼈의 정상 재형성 회로를 가로채 쓰는 것이므로 bisphosphonate와 denosumab 같은 흡수 억제제가 치료에 쓰인다.</a:t>
+              <a:t>소아에서는 거의 모든 뼈에 적색 골수가 있지만 성인에서는 축성 골격과 긴뼈의 몸쪽 끝, 즉 척추, 복장뼈, 갈비뼈, 골반, 넙다리뼈와 위팔뼈의 몸쪽에 남고 나머지는 지방으로 대치된 황색 골수가 된다. 따라서 골수 검사는 적색 골수가 있는 엉덩뼈 능선에서 시행한다. 또 뼈 전이가 적색 골수가 있는 척추, 골반, 갈비뼈에 먼저 나타나는 경향이 있는데, 혈류가 풍부하고 혈관 구조가 느린 흐름을 허용하기 때문으로 설명된다.</a:t>
             </a:r>
           </a:p>
         </p:txBody>
@@ -17160,7 +17193,7 @@
                 <a:ea typeface="Malgun Gothic"/>
                 <a:cs typeface="Malgun Gothic"/>
               </a:rPr>
-              <a:t>Q22   </a:t>
+              <a:t>Q21   </a:t>
             </a:r>
             <a:r>
               <a:rPr sz="2400" b="1" i="0">
@@ -17254,7 +17287,7 @@
                 <a:ea typeface="Malgun Gothic"/>
                 <a:cs typeface="Malgun Gothic"/>
               </a:rPr>
-              <a:t>머리뼈의 성장 방식이 긴뼈와 어떻게 다른지 쓰고, 두개골 조기유합증에서 머리 모양이 변형되는 이유를 설명하시오.</a:t>
+              <a:t>골용해성 전이와 골형성성 전이의 기전을 재형성 조절의 관점에서 설명하고 대표적인 원발암을 드시오.</a:t>
             </a:r>
           </a:p>
         </p:txBody>
@@ -17322,7 +17355,7 @@
                 <a:ea typeface="Malgun Gothic"/>
                 <a:cs typeface="Malgun Gothic"/>
               </a:rPr>
-              <a:t>머리뼈의 납작뼈는 막내골화로 만들어져 성장판이 없고, 뼈와 뼈 사이의 봉합에서 가장자리에 뼈가 더해지며 자란다. 성장을 이끄는 것은 뼈가 아니라 뇌의 부피 증가이며, 자라는 뇌가 봉합을 밀어내면 그 자리에 새 뼈가 더해진다. 따라서 어느 봉합이 일찍 닫히면 그 봉합에 수직인 방향으로는 더 자라지 못하고, 열려 있는 다른 봉합 쪽으로 보상 성장이 일어나 머리 모양이 특징적으로 변형된다. 어느 봉합이 닫혔는지에 따라 변형의 방향이 정해진다.</a:t>
+              <a:t>골용해성 전이는 종양세포가 RANKL 생산을 늘리거나 RANKL을 유도하는 인자를 분비해 osteoclast를 과도하게 활성화한 결과이며, 뼈가 녹아 방사선에서 구멍처럼 보인다. 유방암, 폐암, 다발골수종에서 흔하다. 골형성성 전이는 종양세포가 osteoblast를 자극해 무질서한 뼈가 과도하게 만들어진 것으로 방사선에서 하얗게 보이며 전립선암에서 특징적이다. 두 경우 모두 종양이 뼈의 정상 재형성 회로를 가로채 쓰는 것이므로 bisphosphonate와 denosumab 같은 흡수 억제제가 치료에 쓰인다.</a:t>
             </a:r>
           </a:p>
         </p:txBody>
@@ -17508,7 +17541,7 @@
                 <a:ea typeface="Malgun Gothic"/>
                 <a:cs typeface="Malgun Gothic"/>
               </a:rPr>
-              <a:t>Q23   </a:t>
+              <a:t>Q22   </a:t>
             </a:r>
             <a:r>
               <a:rPr sz="2400" b="1" i="0">
@@ -17602,7 +17635,7 @@
                 <a:ea typeface="Malgun Gothic"/>
                 <a:cs typeface="Malgun Gothic"/>
               </a:rPr>
-              <a:t>치아를 이루는 네 조직을 유래와 재생 가능성으로 구분하고, 충치가 저절로 낫지 않는 이유를 설명하시오.</a:t>
+              <a:t>머리뼈의 성장 방식이 긴뼈와 어떻게 다른지 쓰고, 두개골 조기유합증에서 머리 모양이 변형되는 이유를 설명하시오.</a:t>
             </a:r>
           </a:p>
         </p:txBody>
@@ -17670,7 +17703,7 @@
                 <a:ea typeface="Malgun Gothic"/>
                 <a:cs typeface="Malgun Gothic"/>
               </a:rPr>
-              <a:t>에나멜질은 외배엽에서 유래하고 상아질, 백악질, 치수는 신경능에서 유래한다. 에나멜질은 약 96%가 무기질로 몸에서 가장 단단하지만, 이를 만드는 사기질모세포가 치아가 맹출하면서 사라지므로 한 번 손상되면 복구되지 않는다. 그래서 충치로 파괴된 에나멜질은 저절로 낫지 않고 수복해야 한다. 반면 상아질은 상아질모세포가 치수 쪽에 남아 있어 자극에 반응해 이차 상아질을 더 만들 수 있다.</a:t>
+              <a:t>머리뼈의 납작뼈는 막내골화로 만들어져 성장판이 없고, 뼈와 뼈 사이의 봉합에서 가장자리에 뼈가 더해지며 자란다. 성장을 이끄는 것은 뼈가 아니라 뇌의 부피 증가이며, 자라는 뇌가 봉합을 밀어내면 그 자리에 새 뼈가 더해진다. 따라서 어느 봉합이 일찍 닫히면 그 봉합에 수직인 방향으로는 더 자라지 못하고, 열려 있는 다른 봉합 쪽으로 보상 성장이 일어나 머리 모양이 특징적으로 변형된다. 어느 봉합이 닫혔는지에 따라 변형의 방향이 정해진다.</a:t>
             </a:r>
           </a:p>
         </p:txBody>
@@ -17856,7 +17889,7 @@
                 <a:ea typeface="Malgun Gothic"/>
                 <a:cs typeface="Malgun Gothic"/>
               </a:rPr>
-              <a:t>Q24   </a:t>
+              <a:t>Q23   </a:t>
             </a:r>
             <a:r>
               <a:rPr sz="2400" b="1" i="0">
@@ -17950,7 +17983,7 @@
                 <a:ea typeface="Malgun Gothic"/>
                 <a:cs typeface="Malgun Gothic"/>
               </a:rPr>
-              <a:t>치아 교정에서 치아가 이동하는 기전을 설명하고, 이것이 어떤 일반 원리의 응용인지 쓰시오.</a:t>
+              <a:t>치아를 이루는 네 조직을 유래와 재생 가능성으로 구분하고, 충치가 저절로 낫지 않는 이유를 설명하시오.</a:t>
             </a:r>
           </a:p>
         </p:txBody>
@@ -18018,7 +18051,7 @@
                 <a:ea typeface="Malgun Gothic"/>
                 <a:cs typeface="Malgun Gothic"/>
               </a:rPr>
-              <a:t>치아는 치조골에 직접 융합되어 있지 않고 치주인대로 매달려 있다. 지속적인 힘을 주면 압박을 받는 쪽의 치조골에서 골흡수가 일어나고 당겨지는 쪽에서 골형성이 일어나, 치아가 힘의 방향으로 서서히 이동하고 그 자리에 뼈가 다시 만들어진다. 이는 기계적 자극이 osteocyte를 통해 감지되어 재형성의 방향을 바꾸는 원리, 즉 Wolff 법칙의 임상적 응용이다. 힘의 크기보다 지속성이 중요하며, 과도한 힘은 오히려 치주인대의 혈류를 끊어 괴사와 뿌리 흡수를 일으킨다.</a:t>
+              <a:t>에나멜질은 외배엽에서 유래하고 상아질, 백악질, 치수는 신경능에서 유래한다. 에나멜질은 약 96%가 무기질로 몸에서 가장 단단하지만, 이를 만드는 사기질모세포가 치아가 맹출하면서 사라지므로 한 번 손상되면 복구되지 않는다. 그래서 충치로 파괴된 에나멜질은 저절로 낫지 않고 수복해야 한다. 반면 상아질은 상아질모세포가 치수 쪽에 남아 있어 자극에 반응해 이차 상아질을 더 만들 수 있다.</a:t>
             </a:r>
           </a:p>
         </p:txBody>
@@ -18645,7 +18678,7 @@
                 <a:ea typeface="Malgun Gothic"/>
                 <a:cs typeface="Malgun Gothic"/>
               </a:rPr>
-              <a:t>REFERENCES   </a:t>
+              <a:t>Q24   </a:t>
             </a:r>
             <a:r>
               <a:rPr sz="2400" b="1" i="0">
@@ -18656,7 +18689,7 @@
                 <a:ea typeface="Malgun Gothic"/>
                 <a:cs typeface="Malgun Gothic"/>
               </a:rPr>
-              <a:t>참고문헌</a:t>
+              <a:t>확인 문항</a:t>
             </a:r>
           </a:p>
         </p:txBody>
@@ -18704,6 +18737,354 @@
                 <a:cs typeface="Malgun Gothic"/>
               </a:rPr>
               <a:t>      40</a:t>
+            </a:r>
+          </a:p>
+        </p:txBody>
+      </p:sp>
+      <p:sp>
+        <p:nvSpPr>
+          <p:cNvPr id="7" name="TextBox 6"/>
+          <p:cNvSpPr txBox="1"/>
+          <p:nvPr/>
+        </p:nvSpPr>
+        <p:spPr>
+          <a:xfrm>
+            <a:off x="640080" y="1371600"/>
+            <a:ext cx="10881360" cy="2103120"/>
+          </a:xfrm>
+          <a:prstGeom prst="rect">
+            <a:avLst/>
+          </a:prstGeom>
+          <a:noFill/>
+        </p:spPr>
+        <p:txBody>
+          <a:bodyPr wrap="square" anchor="t">
+            <a:spAutoFit/>
+          </a:bodyPr>
+          <a:lstStyle/>
+          <a:p>
+            <a:r>
+              <a:rPr sz="1900" b="1" i="0">
+                <a:solidFill>
+                  <a:srgbClr val="11202B"/>
+                </a:solidFill>
+                <a:latin typeface="Malgun Gothic"/>
+                <a:ea typeface="Malgun Gothic"/>
+                <a:cs typeface="Malgun Gothic"/>
+              </a:rPr>
+              <a:t>치아 교정에서 치아가 이동하는 기전을 설명하고, 이것이 어떤 일반 원리의 응용인지 쓰시오.</a:t>
+            </a:r>
+          </a:p>
+        </p:txBody>
+      </p:sp>
+      <p:sp>
+        <p:nvSpPr>
+          <p:cNvPr id="8" name="Rectangle 7"/>
+          <p:cNvSpPr/>
+          <p:nvPr/>
+        </p:nvSpPr>
+        <p:spPr>
+          <a:xfrm>
+            <a:off x="640080" y="3657600"/>
+            <a:ext cx="10881360" cy="2606040"/>
+          </a:xfrm>
+          <a:prstGeom prst="rect">
+            <a:avLst/>
+          </a:prstGeom>
+          <a:solidFill>
+            <a:srgbClr val="FFFFFF"/>
+          </a:solidFill>
+          <a:ln>
+            <a:solidFill>
+              <a:srgbClr val="C2CDD6"/>
+            </a:solidFill>
+          </a:ln>
+          <a:effectLst/>
+        </p:spPr>
+        <p:style>
+          <a:lnRef idx="1">
+            <a:schemeClr val="accent1"/>
+          </a:lnRef>
+          <a:fillRef idx="3">
+            <a:schemeClr val="accent1"/>
+          </a:fillRef>
+          <a:effectRef idx="2">
+            <a:schemeClr val="accent1"/>
+          </a:effectRef>
+          <a:fontRef idx="minor">
+            <a:schemeClr val="lt1"/>
+          </a:fontRef>
+        </p:style>
+        <p:txBody>
+          <a:bodyPr rtlCol="0" anchor="ctr" wrap="square" lIns="228600" rIns="228600" tIns="164592"/>
+          <a:lstStyle/>
+          <a:p>
+            <a:pPr algn="l"/>
+            <a:r>
+              <a:rPr sz="1200" b="1" i="0">
+                <a:solidFill>
+                  <a:srgbClr val="003C71"/>
+                </a:solidFill>
+                <a:latin typeface="Malgun Gothic"/>
+                <a:ea typeface="Malgun Gothic"/>
+                <a:cs typeface="Malgun Gothic"/>
+              </a:rPr>
+              <a:t>해설   </a:t>
+            </a:r>
+            <a:r>
+              <a:rPr sz="1500" b="0" i="0">
+                <a:solidFill>
+                  <a:srgbClr val="11202B"/>
+                </a:solidFill>
+                <a:latin typeface="Malgun Gothic"/>
+                <a:ea typeface="Malgun Gothic"/>
+                <a:cs typeface="Malgun Gothic"/>
+              </a:rPr>
+              <a:t>치아는 치조골에 직접 융합되어 있지 않고 치주인대로 매달려 있다. 지속적인 힘을 주면 압박을 받는 쪽의 치조골에서 골흡수가 일어나고 당겨지는 쪽에서 골형성이 일어나, 치아가 힘의 방향으로 서서히 이동하고 그 자리에 뼈가 다시 만들어진다. 이는 기계적 자극이 osteocyte를 통해 감지되어 재형성의 방향을 바꾸는 원리, 즉 Wolff 법칙의 임상적 응용이다. 힘의 크기보다 지속성이 중요하며, 과도한 힘은 오히려 치주인대의 혈류를 끊어 괴사와 뿌리 흡수를 일으킨다.</a:t>
+            </a:r>
+          </a:p>
+        </p:txBody>
+      </p:sp>
+    </p:spTree>
+  </p:cSld>
+  <p:clrMapOvr>
+    <a:masterClrMapping/>
+  </p:clrMapOvr>
+</p:sld>
+</file>
+
+<file path=ppt/slides/slide41.xml><?xml version="1.0" encoding="utf-8"?>
+<p:sld xmlns:a="http://schemas.openxmlformats.org/drawingml/2006/main" xmlns:p="http://schemas.openxmlformats.org/presentationml/2006/main" xmlns:r="http://schemas.openxmlformats.org/officeDocument/2006/relationships">
+  <p:cSld>
+    <p:spTree>
+      <p:nvGrpSpPr>
+        <p:cNvPr id="1" name=""/>
+        <p:cNvGrpSpPr/>
+        <p:nvPr/>
+      </p:nvGrpSpPr>
+      <p:grpSpPr/>
+      <p:sp>
+        <p:nvSpPr>
+          <p:cNvPr id="2" name="Rectangle 1"/>
+          <p:cNvSpPr/>
+          <p:nvPr/>
+        </p:nvSpPr>
+        <p:spPr>
+          <a:xfrm>
+            <a:off x="0" y="0"/>
+            <a:ext cx="12191695" cy="6858000"/>
+          </a:xfrm>
+          <a:prstGeom prst="rect">
+            <a:avLst/>
+          </a:prstGeom>
+          <a:solidFill>
+            <a:srgbClr val="F5F8F9"/>
+          </a:solidFill>
+          <a:ln>
+            <a:noFill/>
+          </a:ln>
+          <a:effectLst/>
+        </p:spPr>
+        <p:style>
+          <a:lnRef idx="1">
+            <a:schemeClr val="accent1"/>
+          </a:lnRef>
+          <a:fillRef idx="3">
+            <a:schemeClr val="accent1"/>
+          </a:fillRef>
+          <a:effectRef idx="2">
+            <a:schemeClr val="accent1"/>
+          </a:effectRef>
+          <a:fontRef idx="minor">
+            <a:schemeClr val="lt1"/>
+          </a:fontRef>
+        </p:style>
+        <p:txBody>
+          <a:bodyPr rtlCol="0" anchor="ctr"/>
+          <a:lstStyle/>
+          <a:p>
+            <a:pPr algn="ctr"/>
+          </a:p>
+        </p:txBody>
+      </p:sp>
+      <p:sp>
+        <p:nvSpPr>
+          <p:cNvPr id="3" name="Rectangle 2"/>
+          <p:cNvSpPr/>
+          <p:nvPr/>
+        </p:nvSpPr>
+        <p:spPr>
+          <a:xfrm>
+            <a:off x="0" y="0"/>
+            <a:ext cx="12191695" cy="960120"/>
+          </a:xfrm>
+          <a:prstGeom prst="rect">
+            <a:avLst/>
+          </a:prstGeom>
+          <a:solidFill>
+            <a:srgbClr val="003C71"/>
+          </a:solidFill>
+          <a:ln>
+            <a:noFill/>
+          </a:ln>
+          <a:effectLst/>
+        </p:spPr>
+        <p:style>
+          <a:lnRef idx="1">
+            <a:schemeClr val="accent1"/>
+          </a:lnRef>
+          <a:fillRef idx="3">
+            <a:schemeClr val="accent1"/>
+          </a:fillRef>
+          <a:effectRef idx="2">
+            <a:schemeClr val="accent1"/>
+          </a:effectRef>
+          <a:fontRef idx="minor">
+            <a:schemeClr val="lt1"/>
+          </a:fontRef>
+        </p:style>
+        <p:txBody>
+          <a:bodyPr rtlCol="0" anchor="ctr"/>
+          <a:lstStyle/>
+          <a:p>
+            <a:pPr algn="ctr"/>
+          </a:p>
+        </p:txBody>
+      </p:sp>
+      <p:sp>
+        <p:nvSpPr>
+          <p:cNvPr id="4" name="Rectangle 3"/>
+          <p:cNvSpPr/>
+          <p:nvPr/>
+        </p:nvSpPr>
+        <p:spPr>
+          <a:xfrm>
+            <a:off x="0" y="960120"/>
+            <a:ext cx="12191695" cy="54864"/>
+          </a:xfrm>
+          <a:prstGeom prst="rect">
+            <a:avLst/>
+          </a:prstGeom>
+          <a:solidFill>
+            <a:srgbClr val="F2B705"/>
+          </a:solidFill>
+          <a:ln>
+            <a:noFill/>
+          </a:ln>
+          <a:effectLst/>
+        </p:spPr>
+        <p:style>
+          <a:lnRef idx="1">
+            <a:schemeClr val="accent1"/>
+          </a:lnRef>
+          <a:fillRef idx="3">
+            <a:schemeClr val="accent1"/>
+          </a:fillRef>
+          <a:effectRef idx="2">
+            <a:schemeClr val="accent1"/>
+          </a:effectRef>
+          <a:fontRef idx="minor">
+            <a:schemeClr val="lt1"/>
+          </a:fontRef>
+        </p:style>
+        <p:txBody>
+          <a:bodyPr rtlCol="0" anchor="ctr"/>
+          <a:lstStyle/>
+          <a:p>
+            <a:pPr algn="ctr"/>
+          </a:p>
+        </p:txBody>
+      </p:sp>
+      <p:sp>
+        <p:nvSpPr>
+          <p:cNvPr id="5" name="TextBox 4"/>
+          <p:cNvSpPr txBox="1"/>
+          <p:nvPr/>
+        </p:nvSpPr>
+        <p:spPr>
+          <a:xfrm>
+            <a:off x="457200" y="109728"/>
+            <a:ext cx="11247120" cy="777240"/>
+          </a:xfrm>
+          <a:prstGeom prst="rect">
+            <a:avLst/>
+          </a:prstGeom>
+          <a:noFill/>
+        </p:spPr>
+        <p:txBody>
+          <a:bodyPr wrap="square" anchor="ctr">
+            <a:spAutoFit/>
+          </a:bodyPr>
+          <a:lstStyle/>
+          <a:p>
+            <a:r>
+              <a:rPr sz="1300" b="1" i="0">
+                <a:solidFill>
+                  <a:srgbClr val="F2B705"/>
+                </a:solidFill>
+                <a:latin typeface="Malgun Gothic"/>
+                <a:ea typeface="Malgun Gothic"/>
+                <a:cs typeface="Malgun Gothic"/>
+              </a:rPr>
+              <a:t>REFERENCES   </a:t>
+            </a:r>
+            <a:r>
+              <a:rPr sz="2400" b="1" i="0">
+                <a:solidFill>
+                  <a:srgbClr val="FFFFFF"/>
+                </a:solidFill>
+                <a:latin typeface="Malgun Gothic"/>
+                <a:ea typeface="Malgun Gothic"/>
+                <a:cs typeface="Malgun Gothic"/>
+              </a:rPr>
+              <a:t>참고문헌</a:t>
+            </a:r>
+          </a:p>
+        </p:txBody>
+      </p:sp>
+      <p:sp>
+        <p:nvSpPr>
+          <p:cNvPr id="6" name="TextBox 5"/>
+          <p:cNvSpPr txBox="1"/>
+          <p:nvPr/>
+        </p:nvSpPr>
+        <p:spPr>
+          <a:xfrm>
+            <a:off x="457200" y="6446520"/>
+            <a:ext cx="11247120" cy="301752"/>
+          </a:xfrm>
+          <a:prstGeom prst="rect">
+            <a:avLst/>
+          </a:prstGeom>
+          <a:noFill/>
+        </p:spPr>
+        <p:txBody>
+          <a:bodyPr wrap="square" anchor="ctr">
+            <a:spAutoFit/>
+          </a:bodyPr>
+          <a:lstStyle/>
+          <a:p>
+            <a:r>
+              <a:rPr sz="900" b="0" i="0">
+                <a:solidFill>
+                  <a:srgbClr val="66788A"/>
+                </a:solidFill>
+                <a:latin typeface="Malgun Gothic"/>
+                <a:ea typeface="Malgun Gothic"/>
+                <a:cs typeface="Malgun Gothic"/>
+              </a:rPr>
+              <a:t>M01-W04-L01  ·  골학 요약: 골격·관절·뼈의 재형성</a:t>
+            </a:r>
+            <a:r>
+              <a:rPr sz="900" b="1" i="0">
+                <a:solidFill>
+                  <a:srgbClr val="003C71"/>
+                </a:solidFill>
+                <a:latin typeface="Malgun Gothic"/>
+                <a:ea typeface="Malgun Gothic"/>
+                <a:cs typeface="Malgun Gothic"/>
+              </a:rPr>
+              <a:t>      41</a:t>
             </a:r>
           </a:p>
         </p:txBody>

</xml_diff>